<commit_message>
Say where the KOI script comes from, and that the List has sample content
"A KOI script in Action Center" reads as a Cortex script to anyone who did not build
this. It is KOI's own deployment script, downloaded from their KOI console and then
uploaded to Action Center, and it must take no parameters. The guide now says so.

The List step also assumed the reader would invent the JSON. It now points at the sample
content that ships with the pack and names the two fields they actually have to change —
the endpoint group and the KOI script name as it appears in Action Center — with one
entry per operating system, and notes that the remaining values have working defaults.

Co-Authored-By: Claude Fable 5 <noreply@anthropic.com>
</commit_message>
<xml_diff>
--- a/docs/KOI_Marketplace_Pack_Test_Guide.pptx
+++ b/docs/KOI_Marketplace_Pack_Test_Guide.pptx
@@ -5249,7 +5249,7 @@
                 <a:ea typeface="Calibri" pitchFamily="34" charset="-122"/>
                 <a:cs typeface="Calibri" pitchFamily="34" charset="-120"/>
               </a:rPr>
-              <a:t>A KOI script in Action Center → Scripts Library (it must take no parameters)</a:t>
+              <a:t>The KOI deployment script — download it from YOUR KOI console, then upload it to Action Center → Scripts Library. This is KOI's script, not a Cortex one. It must take no parameters</a:t>
             </a:r>
             <a:endParaRPr lang="en-US" sz="1050" dirty="0"/>
           </a:p>
@@ -5405,7 +5405,7 @@
                 <a:ea typeface="Calibri" pitchFamily="34" charset="-122"/>
                 <a:cs typeface="Calibri" pitchFamily="34" charset="-120"/>
               </a:rPr>
-              <a:t>A JSON List named exactly "Koi Script Runner"</a:t>
+              <a:t>A JSON List named exactly "Koi Script Runner" — sample content ships with this pack</a:t>
             </a:r>
             <a:endParaRPr lang="en-US" sz="1050" dirty="0"/>
           </a:p>
@@ -5420,11 +5420,11 @@
         <p:spPr>
           <a:xfrm>
             <a:off x="548640" y="2651760"/>
-            <a:ext cx="6400800" cy="2665476"/>
+            <a:ext cx="6400800" cy="3200400"/>
           </a:xfrm>
           <a:prstGeom prst="roundRect">
             <a:avLst>
-              <a:gd name="adj" fmla="val 1715"/>
+              <a:gd name="adj" fmla="val 1429"/>
             </a:avLst>
           </a:prstGeom>
           <a:solidFill>
@@ -5552,7 +5552,7 @@
                 <a:ea typeface="Calibri" pitchFamily="34" charset="-122"/>
                 <a:cs typeface="Calibri" pitchFamily="34" charset="-120"/>
               </a:rPr>
-              <a:t>Settings → Object Setup → Lists → New List, type JSON, named Koi Script Runner.</a:t>
+              <a:t>Settings → Object Setup → Lists → New List, type JSON, named exactly Koi Script Runner.</a:t>
             </a:r>
             <a:endParaRPr lang="en-US" sz="1150" dirty="0"/>
           </a:p>
@@ -5633,7 +5633,7 @@
                 <a:ea typeface="Calibri" pitchFamily="34" charset="-122"/>
                 <a:cs typeface="Calibri" pitchFamily="34" charset="-120"/>
               </a:rPr>
-              <a:t>Give each entry a script name, endpoint_os, endpoint group, tracker_list and rescan_interval_hours.</a:t>
+              <a:t>Paste the sample list content that ships with this pack (see the pack README), then edit it.</a:t>
             </a:r>
             <a:endParaRPr lang="en-US" sz="1150" dirty="0"/>
           </a:p>
@@ -5714,7 +5714,7 @@
                 <a:ea typeface="Calibri" pitchFamily="34" charset="-122"/>
                 <a:cs typeface="Calibri" pitchFamily="34" charset="-120"/>
               </a:rPr>
-              <a:t>Automation → Jobs → New Job → time-triggered → playbook KOI Ext Script Runner - Refresh Job.</a:t>
+              <a:t>Set endpoint_groups to your group name and script.name to the KOI script exactly as it appears in Action Center.</a:t>
             </a:r>
             <a:endParaRPr lang="en-US" sz="1150" dirty="0"/>
           </a:p>
@@ -5768,7 +5768,7 @@
         <p:spPr>
           <a:xfrm>
             <a:off x="1152144" y="4768596"/>
-            <a:ext cx="5486400" cy="246888"/>
+            <a:ext cx="5486400" cy="438912"/>
           </a:xfrm>
           <a:prstGeom prst="rect">
             <a:avLst/>
@@ -5795,6 +5795,249 @@
                 <a:ea typeface="Calibri" pitchFamily="34" charset="-122"/>
                 <a:cs typeface="Calibri" pitchFamily="34" charset="-120"/>
               </a:rPr>
+              <a:t>Add one entry per operating system you deploy to — each entry pairs one script with one OS.</a:t>
+            </a:r>
+            <a:endParaRPr lang="en-US" sz="1150" dirty="0"/>
+          </a:p>
+        </p:txBody>
+      </p:sp>
+      <p:sp>
+        <p:nvSpPr>
+          <p:cNvPr id="24" name="Text 22"/>
+          <p:cNvSpPr/>
+          <p:nvPr/>
+        </p:nvSpPr>
+        <p:spPr>
+          <a:xfrm>
+            <a:off x="859536" y="5285232"/>
+            <a:ext cx="219456" cy="256032"/>
+          </a:xfrm>
+          <a:prstGeom prst="rect">
+            <a:avLst/>
+          </a:prstGeom>
+          <a:noFill/>
+          <a:ln/>
+        </p:spPr>
+        <p:txBody>
+          <a:bodyPr wrap="square" lIns="0" tIns="0" rIns="0" bIns="0" rtlCol="0" anchor="t"/>
+          <a:lstStyle/>
+          <a:p>
+            <a:pPr indent="0" marL="0">
+              <a:buNone/>
+            </a:pPr>
+            <a:r>
+              <a:rPr lang="en-US" sz="1150" b="1" dirty="0">
+                <a:solidFill>
+                  <a:srgbClr val="E8551F"/>
+                </a:solidFill>
+                <a:latin typeface="Calibri" pitchFamily="34" charset="0"/>
+                <a:ea typeface="Calibri" pitchFamily="34" charset="-122"/>
+                <a:cs typeface="Calibri" pitchFamily="34" charset="-120"/>
+              </a:rPr>
+              <a:t>5</a:t>
+            </a:r>
+            <a:endParaRPr lang="en-US" sz="1150" dirty="0"/>
+          </a:p>
+        </p:txBody>
+      </p:sp>
+      <p:sp>
+        <p:nvSpPr>
+          <p:cNvPr id="25" name="Text 23"/>
+          <p:cNvSpPr/>
+          <p:nvPr/>
+        </p:nvSpPr>
+        <p:spPr>
+          <a:xfrm>
+            <a:off x="1152144" y="5285232"/>
+            <a:ext cx="5486400" cy="438912"/>
+          </a:xfrm>
+          <a:prstGeom prst="rect">
+            <a:avLst/>
+          </a:prstGeom>
+          <a:noFill/>
+          <a:ln/>
+        </p:spPr>
+        <p:txBody>
+          <a:bodyPr wrap="square" lIns="0" tIns="0" rIns="0" bIns="0" rtlCol="0" anchor="t"/>
+          <a:lstStyle/>
+          <a:p>
+            <a:pPr indent="0" marL="0">
+              <a:lnSpc>
+                <a:spcPts val="1500"/>
+              </a:lnSpc>
+              <a:buNone/>
+            </a:pPr>
+            <a:r>
+              <a:rPr lang="en-US" sz="1150" dirty="0">
+                <a:solidFill>
+                  <a:srgbClr val="B4B7BD"/>
+                </a:solidFill>
+                <a:latin typeface="Calibri" pitchFamily="34" charset="0"/>
+                <a:ea typeface="Calibri" pitchFamily="34" charset="-122"/>
+                <a:cs typeface="Calibri" pitchFamily="34" charset="-120"/>
+              </a:rPr>
+              <a:t>tracker_list and rescan_interval_hours already carry working defaults — leave them unless you want a different rescan window.</a:t>
+            </a:r>
+            <a:endParaRPr lang="en-US" sz="1150" dirty="0"/>
+          </a:p>
+        </p:txBody>
+      </p:sp>
+      <p:sp>
+        <p:nvSpPr>
+          <p:cNvPr id="26" name="Text 24"/>
+          <p:cNvSpPr/>
+          <p:nvPr/>
+        </p:nvSpPr>
+        <p:spPr>
+          <a:xfrm>
+            <a:off x="859536" y="5801868"/>
+            <a:ext cx="219456" cy="256032"/>
+          </a:xfrm>
+          <a:prstGeom prst="rect">
+            <a:avLst/>
+          </a:prstGeom>
+          <a:noFill/>
+          <a:ln/>
+        </p:spPr>
+        <p:txBody>
+          <a:bodyPr wrap="square" lIns="0" tIns="0" rIns="0" bIns="0" rtlCol="0" anchor="t"/>
+          <a:lstStyle/>
+          <a:p>
+            <a:pPr indent="0" marL="0">
+              <a:buNone/>
+            </a:pPr>
+            <a:r>
+              <a:rPr lang="en-US" sz="1150" b="1" dirty="0">
+                <a:solidFill>
+                  <a:srgbClr val="E8551F"/>
+                </a:solidFill>
+                <a:latin typeface="Calibri" pitchFamily="34" charset="0"/>
+                <a:ea typeface="Calibri" pitchFamily="34" charset="-122"/>
+                <a:cs typeface="Calibri" pitchFamily="34" charset="-120"/>
+              </a:rPr>
+              <a:t>6</a:t>
+            </a:r>
+            <a:endParaRPr lang="en-US" sz="1150" dirty="0"/>
+          </a:p>
+        </p:txBody>
+      </p:sp>
+      <p:sp>
+        <p:nvSpPr>
+          <p:cNvPr id="27" name="Text 25"/>
+          <p:cNvSpPr/>
+          <p:nvPr/>
+        </p:nvSpPr>
+        <p:spPr>
+          <a:xfrm>
+            <a:off x="1152144" y="5801868"/>
+            <a:ext cx="5486400" cy="438912"/>
+          </a:xfrm>
+          <a:prstGeom prst="rect">
+            <a:avLst/>
+          </a:prstGeom>
+          <a:noFill/>
+          <a:ln/>
+        </p:spPr>
+        <p:txBody>
+          <a:bodyPr wrap="square" lIns="0" tIns="0" rIns="0" bIns="0" rtlCol="0" anchor="t"/>
+          <a:lstStyle/>
+          <a:p>
+            <a:pPr indent="0" marL="0">
+              <a:lnSpc>
+                <a:spcPts val="1500"/>
+              </a:lnSpc>
+              <a:buNone/>
+            </a:pPr>
+            <a:r>
+              <a:rPr lang="en-US" sz="1150" dirty="0">
+                <a:solidFill>
+                  <a:srgbClr val="B4B7BD"/>
+                </a:solidFill>
+                <a:latin typeface="Calibri" pitchFamily="34" charset="0"/>
+                <a:ea typeface="Calibri" pitchFamily="34" charset="-122"/>
+                <a:cs typeface="Calibri" pitchFamily="34" charset="-120"/>
+              </a:rPr>
+              <a:t>Automation → Jobs → New Job → time-triggered → playbook KOI Ext Script Runner - Refresh Job.</a:t>
+            </a:r>
+            <a:endParaRPr lang="en-US" sz="1150" dirty="0"/>
+          </a:p>
+        </p:txBody>
+      </p:sp>
+      <p:sp>
+        <p:nvSpPr>
+          <p:cNvPr id="28" name="Text 26"/>
+          <p:cNvSpPr/>
+          <p:nvPr/>
+        </p:nvSpPr>
+        <p:spPr>
+          <a:xfrm>
+            <a:off x="859536" y="6318504"/>
+            <a:ext cx="219456" cy="256032"/>
+          </a:xfrm>
+          <a:prstGeom prst="rect">
+            <a:avLst/>
+          </a:prstGeom>
+          <a:noFill/>
+          <a:ln/>
+        </p:spPr>
+        <p:txBody>
+          <a:bodyPr wrap="square" lIns="0" tIns="0" rIns="0" bIns="0" rtlCol="0" anchor="t"/>
+          <a:lstStyle/>
+          <a:p>
+            <a:pPr indent="0" marL="0">
+              <a:buNone/>
+            </a:pPr>
+            <a:r>
+              <a:rPr lang="en-US" sz="1150" b="1" dirty="0">
+                <a:solidFill>
+                  <a:srgbClr val="E8551F"/>
+                </a:solidFill>
+                <a:latin typeface="Calibri" pitchFamily="34" charset="0"/>
+                <a:ea typeface="Calibri" pitchFamily="34" charset="-122"/>
+                <a:cs typeface="Calibri" pitchFamily="34" charset="-120"/>
+              </a:rPr>
+              <a:t>7</a:t>
+            </a:r>
+            <a:endParaRPr lang="en-US" sz="1150" dirty="0"/>
+          </a:p>
+        </p:txBody>
+      </p:sp>
+      <p:sp>
+        <p:nvSpPr>
+          <p:cNvPr id="29" name="Text 27"/>
+          <p:cNvSpPr/>
+          <p:nvPr/>
+        </p:nvSpPr>
+        <p:spPr>
+          <a:xfrm>
+            <a:off x="1152144" y="6318504"/>
+            <a:ext cx="5486400" cy="246888"/>
+          </a:xfrm>
+          <a:prstGeom prst="rect">
+            <a:avLst/>
+          </a:prstGeom>
+          <a:noFill/>
+          <a:ln/>
+        </p:spPr>
+        <p:txBody>
+          <a:bodyPr wrap="square" lIns="0" tIns="0" rIns="0" bIns="0" rtlCol="0" anchor="t"/>
+          <a:lstStyle/>
+          <a:p>
+            <a:pPr indent="0" marL="0">
+              <a:lnSpc>
+                <a:spcPts val="1500"/>
+              </a:lnSpc>
+              <a:buNone/>
+            </a:pPr>
+            <a:r>
+              <a:rPr lang="en-US" sz="1150" dirty="0">
+                <a:solidFill>
+                  <a:srgbClr val="B4B7BD"/>
+                </a:solidFill>
+                <a:latin typeface="Calibri" pitchFamily="34" charset="0"/>
+                <a:ea typeface="Calibri" pitchFamily="34" charset="-122"/>
+                <a:cs typeface="Calibri" pitchFamily="34" charset="-120"/>
+              </a:rPr>
               <a:t>Enable the Job, then Run now.</a:t>
             </a:r>
             <a:endParaRPr lang="en-US" sz="1150" dirty="0"/>
@@ -5803,18 +6046,18 @@
       </p:sp>
       <p:sp>
         <p:nvSpPr>
-          <p:cNvPr id="24" name="Shape 22"/>
+          <p:cNvPr id="30" name="Shape 28"/>
           <p:cNvSpPr/>
           <p:nvPr/>
         </p:nvSpPr>
         <p:spPr>
           <a:xfrm>
             <a:off x="7315200" y="2651760"/>
-            <a:ext cx="4297680" cy="2665476"/>
+            <a:ext cx="4297680" cy="3200400"/>
           </a:xfrm>
           <a:prstGeom prst="roundRect">
             <a:avLst>
-              <a:gd name="adj" fmla="val 1715"/>
+              <a:gd name="adj" fmla="val 1429"/>
             </a:avLst>
           </a:prstGeom>
           <a:solidFill>
@@ -5830,7 +6073,7 @@
       </p:sp>
       <p:sp>
         <p:nvSpPr>
-          <p:cNvPr id="25" name="Text 23"/>
+          <p:cNvPr id="31" name="Text 29"/>
           <p:cNvSpPr/>
           <p:nvPr/>
         </p:nvSpPr>
@@ -5869,7 +6112,7 @@
       </p:sp>
       <p:sp>
         <p:nvSpPr>
-          <p:cNvPr id="26" name="Text 24"/>
+          <p:cNvPr id="32" name="Text 30"/>
           <p:cNvSpPr/>
           <p:nvPr/>
         </p:nvSpPr>
@@ -5908,7 +6151,7 @@
       </p:sp>
       <p:sp>
         <p:nvSpPr>
-          <p:cNvPr id="27" name="Text 25"/>
+          <p:cNvPr id="33" name="Text 31"/>
           <p:cNvSpPr/>
           <p:nvPr/>
         </p:nvSpPr>
@@ -5950,7 +6193,7 @@
       </p:sp>
       <p:sp>
         <p:nvSpPr>
-          <p:cNvPr id="28" name="Text 26"/>
+          <p:cNvPr id="34" name="Text 32"/>
           <p:cNvSpPr/>
           <p:nvPr/>
         </p:nvSpPr>
@@ -5989,7 +6232,7 @@
       </p:sp>
       <p:sp>
         <p:nvSpPr>
-          <p:cNvPr id="29" name="Text 27"/>
+          <p:cNvPr id="35" name="Text 33"/>
           <p:cNvSpPr/>
           <p:nvPr/>
         </p:nvSpPr>
@@ -6031,7 +6274,7 @@
       </p:sp>
       <p:sp>
         <p:nvSpPr>
-          <p:cNvPr id="30" name="Text 28"/>
+          <p:cNvPr id="36" name="Text 34"/>
           <p:cNvSpPr/>
           <p:nvPr/>
         </p:nvSpPr>
@@ -6070,7 +6313,7 @@
       </p:sp>
       <p:sp>
         <p:nvSpPr>
-          <p:cNvPr id="31" name="Text 29"/>
+          <p:cNvPr id="37" name="Text 35"/>
           <p:cNvSpPr/>
           <p:nvPr/>
         </p:nvSpPr>
@@ -6112,13 +6355,13 @@
       </p:sp>
       <p:sp>
         <p:nvSpPr>
-          <p:cNvPr id="32" name="Shape 30"/>
-          <p:cNvSpPr/>
-          <p:nvPr/>
-        </p:nvSpPr>
-        <p:spPr>
-          <a:xfrm>
-            <a:off x="548640" y="5463540"/>
+          <p:cNvPr id="38" name="Shape 36"/>
+          <p:cNvSpPr/>
+          <p:nvPr/>
+        </p:nvSpPr>
+        <p:spPr>
+          <a:xfrm>
+            <a:off x="548640" y="5998464"/>
             <a:ext cx="11064240" cy="658368"/>
           </a:xfrm>
           <a:prstGeom prst="roundRect">
@@ -6139,13 +6382,13 @@
       </p:sp>
       <p:sp>
         <p:nvSpPr>
-          <p:cNvPr id="33" name="Shape 31"/>
-          <p:cNvSpPr/>
-          <p:nvPr/>
-        </p:nvSpPr>
-        <p:spPr>
-          <a:xfrm>
-            <a:off x="786384" y="5646420"/>
+          <p:cNvPr id="39" name="Shape 37"/>
+          <p:cNvSpPr/>
+          <p:nvPr/>
+        </p:nvSpPr>
+        <p:spPr>
+          <a:xfrm>
+            <a:off x="786384" y="6181344"/>
             <a:ext cx="292608" cy="292608"/>
           </a:xfrm>
           <a:prstGeom prst="roundRect">
@@ -6166,13 +6409,13 @@
       </p:sp>
       <p:sp>
         <p:nvSpPr>
-          <p:cNvPr id="34" name="Text 32"/>
-          <p:cNvSpPr/>
-          <p:nvPr/>
-        </p:nvSpPr>
-        <p:spPr>
-          <a:xfrm>
-            <a:off x="786384" y="5646420"/>
+          <p:cNvPr id="40" name="Text 38"/>
+          <p:cNvSpPr/>
+          <p:nvPr/>
+        </p:nvSpPr>
+        <p:spPr>
+          <a:xfrm>
+            <a:off x="786384" y="6181344"/>
             <a:ext cx="292608" cy="292608"/>
           </a:xfrm>
           <a:prstGeom prst="rect">
@@ -6205,13 +6448,13 @@
       </p:sp>
       <p:sp>
         <p:nvSpPr>
-          <p:cNvPr id="35" name="Text 33"/>
-          <p:cNvSpPr/>
-          <p:nvPr/>
-        </p:nvSpPr>
-        <p:spPr>
-          <a:xfrm>
-            <a:off x="1243584" y="5573268"/>
+          <p:cNvPr id="41" name="Text 39"/>
+          <p:cNvSpPr/>
+          <p:nvPr/>
+        </p:nvSpPr>
+        <p:spPr>
+          <a:xfrm>
+            <a:off x="1243584" y="6108192"/>
             <a:ext cx="10058400" cy="438912"/>
           </a:xfrm>
           <a:prstGeom prst="rect">

</xml_diff>

<commit_message>
Give the List sample a form a human can actually paste
The shipped content item is correct — a List's data field is a JSON string, so its JSON
is escaped and the platform unescapes it on install. But the guide said to copy that data
value, and copying it by hand pastes literal backslash-n and produces a List the playbook
cannot parse.

Lists/README.md now carries the same JSON as a plain fenced block — indented, real
newlines, no escapes — with a table of which fields to change and which to leave. The
test guide points there and says not to copy from the content item.

Verified by pasting the block's exact text into a List on a tenant and parsing it the way
the playbook does: two entries, no escapes, both resolving.

Co-Authored-By: Claude Fable 5 <noreply@anthropic.com>
</commit_message>
<xml_diff>
--- a/docs/KOI_Marketplace_Pack_Test_Guide.pptx
+++ b/docs/KOI_Marketplace_Pack_Test_Guide.pptx
@@ -6479,7 +6479,7 @@
         <p:spPr>
           <a:xfrm>
             <a:off x="1152144" y="4279392"/>
-            <a:ext cx="5486400" cy="438912"/>
+            <a:ext cx="5486400" cy="630936"/>
           </a:xfrm>
           <a:prstGeom prst="rect">
             <a:avLst/>
@@ -6506,7 +6506,7 @@
                 <a:ea typeface="Calibri" pitchFamily="34" charset="-122"/>
                 <a:cs typeface="Calibri" pitchFamily="34" charset="-120"/>
               </a:rPr>
-              <a:t>Open Lists/list-Koi_Script_Runner.json in the pack, copy its data value, and paste it in.</a:t>
+              <a:t>Open Lists/README.md in the pack and copy the JSON block — it is formatted ready to paste (do NOT copy from list-Koi_Script_Runner.json; its data field is escaped).</a:t>
             </a:r>
             <a:endParaRPr lang="en-US" sz="1150" dirty="0"/>
           </a:p>
@@ -6520,7 +6520,7 @@
         </p:nvSpPr>
         <p:spPr>
           <a:xfrm>
-            <a:off x="859536" y="4796028"/>
+            <a:off x="859536" y="4983480"/>
             <a:ext cx="219456" cy="256032"/>
           </a:xfrm>
           <a:prstGeom prst="rect">
@@ -6559,7 +6559,7 @@
         </p:nvSpPr>
         <p:spPr>
           <a:xfrm>
-            <a:off x="1152144" y="4796028"/>
+            <a:off x="1152144" y="4983480"/>
             <a:ext cx="5486400" cy="438912"/>
           </a:xfrm>
           <a:prstGeom prst="rect">
@@ -6601,7 +6601,7 @@
         </p:nvSpPr>
         <p:spPr>
           <a:xfrm>
-            <a:off x="859536" y="5312664"/>
+            <a:off x="859536" y="5500116"/>
             <a:ext cx="219456" cy="256032"/>
           </a:xfrm>
           <a:prstGeom prst="rect">
@@ -6640,7 +6640,7 @@
         </p:nvSpPr>
         <p:spPr>
           <a:xfrm>
-            <a:off x="1152144" y="5312664"/>
+            <a:off x="1152144" y="5500116"/>
             <a:ext cx="5486400" cy="438912"/>
           </a:xfrm>
           <a:prstGeom prst="rect">
@@ -6682,7 +6682,7 @@
         </p:nvSpPr>
         <p:spPr>
           <a:xfrm>
-            <a:off x="859536" y="5829300"/>
+            <a:off x="859536" y="6016752"/>
             <a:ext cx="219456" cy="256032"/>
           </a:xfrm>
           <a:prstGeom prst="rect">
@@ -6721,7 +6721,7 @@
         </p:nvSpPr>
         <p:spPr>
           <a:xfrm>
-            <a:off x="1152144" y="5829300"/>
+            <a:off x="1152144" y="6016752"/>
             <a:ext cx="5486400" cy="438912"/>
           </a:xfrm>
           <a:prstGeom prst="rect">

</xml_diff>

<commit_message>
Strip troubleshooting from the test guide
Mirrors the custom pack. The guide is a checklist for running the tests, not a diagnostic
manual — symptom/cause/fix belongs in the troubleshooting guide only.

Removed the troubleshooting slide, the caveat bar under every test, and the intro framing
about prerequisites being the thing to check when something looks like a product fault.
The SKIPPED and STILL RUNNING outcomes moved into "What to expect" for the scan test,
because they are normal results rather than problems.

16 slides down to 15, no overflow, none of the troubleshooting vocabulary left in the
rendered deck.

Co-Authored-By: Claude Fable 5 <noreply@anthropic.com>
</commit_message>
<xml_diff>
--- a/docs/KOI_Marketplace_Pack_Test_Guide.pptx
+++ b/docs/KOI_Marketplace_Pack_Test_Guide.pptx
@@ -20,10 +20,9 @@
     <p:sldId id="268" r:id="rId14"/>
     <p:sldId id="269" r:id="rId15"/>
     <p:sldId id="270" r:id="rId16"/>
-    <p:sldId id="271" r:id="rId17"/>
   </p:sldIdLst>
   <p:notesMasterIdLst>
-    <p:notesMasterId r:id="rId18"/>
+    <p:notesMasterId r:id="rId17"/>
   </p:notesMasterIdLst>
   <p:sldSz cx="12192000" cy="6858000"/>
   <p:notesSz cx="6858000" cy="12192000"/>
@@ -1069,94 +1068,6 @@
             <a:fld id="{F7021451-1387-4CA6-816F-3879F97B5CBC}" type="slidenum">
               <a:rPr lang="en-US"/>
               <a:t>15</a:t>
-            </a:fld>
-            <a:endParaRPr lang="en-US"/>
-          </a:p>
-        </p:txBody>
-      </p:sp>
-    </p:spTree>
-    <p:extLst>
-      <p:ext uri="{BB962C8B-B14F-4D97-AF65-F5344CB8AC3E}">
-        <p14:creationId xmlns:p14="http://schemas.microsoft.com/office/powerpoint/2010/main" val="1024086991"/>
-      </p:ext>
-    </p:extLst>
-  </p:cSld>
-  <p:clrMapOvr>
-    <a:masterClrMapping/>
-  </p:clrMapOvr>
-</p:notes>
-</file>
-
-<file path=ppt/notesSlides/notesSlide16.xml><?xml version="1.0" encoding="utf-8"?>
-<p:notes xmlns:a="http://schemas.openxmlformats.org/drawingml/2006/main" xmlns:r="http://schemas.openxmlformats.org/officeDocument/2006/relationships" xmlns:p="http://schemas.openxmlformats.org/presentationml/2006/main">
-  <p:cSld>
-    <p:spTree>
-      <p:nvGrpSpPr>
-        <p:cNvPr id="1" name=""/>
-        <p:cNvGrpSpPr/>
-        <p:nvPr/>
-      </p:nvGrpSpPr>
-      <p:grpSpPr>
-        <a:xfrm>
-          <a:off x="0" y="0"/>
-          <a:ext cx="0" cy="0"/>
-          <a:chOff x="0" y="0"/>
-          <a:chExt cx="0" cy="0"/>
-        </a:xfrm>
-      </p:grpSpPr>
-      <p:sp>
-        <p:nvSpPr>
-          <p:cNvPr id="2" name="Slide Image Placeholder 1"/>
-          <p:cNvSpPr>
-            <a:spLocks noGrp="1" noRot="1" noChangeAspect="1"/>
-          </p:cNvSpPr>
-          <p:nvPr>
-            <p:ph type="sldImg"/>
-          </p:nvPr>
-        </p:nvSpPr>
-        <p:spPr/>
-      </p:sp>
-      <p:sp>
-        <p:nvSpPr>
-          <p:cNvPr id="3" name="Notes Placeholder 2"/>
-          <p:cNvSpPr>
-            <a:spLocks noGrp="1"/>
-          </p:cNvSpPr>
-          <p:nvPr>
-            <p:ph type="body" idx="1"/>
-          </p:nvPr>
-        </p:nvSpPr>
-        <p:spPr/>
-        <p:txBody>
-          <a:bodyPr/>
-          <a:lstStyle/>
-          <a:p>
-            <a:r>
-              <a:rPr lang="en-US" dirty="0"/>
-              <a:t/>
-            </a:r>
-            <a:endParaRPr lang="en-US" dirty="0"/>
-          </a:p>
-        </p:txBody>
-      </p:sp>
-      <p:sp>
-        <p:nvSpPr>
-          <p:cNvPr id="4" name="Slide Number Placeholder 3"/>
-          <p:cNvSpPr>
-            <a:spLocks noGrp="1"/>
-          </p:cNvSpPr>
-          <p:nvPr>
-            <p:ph type="sldNum" sz="quarter" idx="10"/>
-          </p:nvPr>
-        </p:nvSpPr>
-        <p:spPr/>
-        <p:txBody>
-          <a:bodyPr/>
-          <a:lstStyle/>
-          <a:p>
-            <a:fld id="{F7021451-1387-4CA6-816F-3879F97B5CBC}" type="slidenum">
-              <a:rPr lang="en-US"/>
-              <a:t>16</a:t>
             </a:fld>
             <a:endParaRPr lang="en-US"/>
           </a:p>
@@ -3832,141 +3743,6 @@
           </a:p>
         </p:txBody>
       </p:sp>
-      <p:sp>
-        <p:nvSpPr>
-          <p:cNvPr id="37" name="Shape 35"/>
-          <p:cNvSpPr/>
-          <p:nvPr/>
-        </p:nvSpPr>
-        <p:spPr>
-          <a:xfrm>
-            <a:off x="548640" y="5052060"/>
-            <a:ext cx="11064240" cy="658368"/>
-          </a:xfrm>
-          <a:prstGeom prst="roundRect">
-            <a:avLst>
-              <a:gd name="adj" fmla="val 6944"/>
-            </a:avLst>
-          </a:prstGeom>
-          <a:solidFill>
-            <a:srgbClr val="1C2026"/>
-          </a:solidFill>
-          <a:ln w="12700">
-            <a:solidFill>
-              <a:srgbClr val="1C2026"/>
-            </a:solidFill>
-            <a:prstDash val="solid"/>
-          </a:ln>
-        </p:spPr>
-      </p:sp>
-      <p:sp>
-        <p:nvSpPr>
-          <p:cNvPr id="38" name="Shape 36"/>
-          <p:cNvSpPr/>
-          <p:nvPr/>
-        </p:nvSpPr>
-        <p:spPr>
-          <a:xfrm>
-            <a:off x="786384" y="5234940"/>
-            <a:ext cx="292608" cy="292608"/>
-          </a:xfrm>
-          <a:prstGeom prst="roundRect">
-            <a:avLst>
-              <a:gd name="adj" fmla="val 28125"/>
-            </a:avLst>
-          </a:prstGeom>
-          <a:solidFill>
-            <a:srgbClr val="F5A524"/>
-          </a:solidFill>
-          <a:ln w="12700">
-            <a:solidFill>
-              <a:srgbClr val="F5A524"/>
-            </a:solidFill>
-            <a:prstDash val="solid"/>
-          </a:ln>
-        </p:spPr>
-      </p:sp>
-      <p:sp>
-        <p:nvSpPr>
-          <p:cNvPr id="39" name="Text 37"/>
-          <p:cNvSpPr/>
-          <p:nvPr/>
-        </p:nvSpPr>
-        <p:spPr>
-          <a:xfrm>
-            <a:off x="786384" y="5234940"/>
-            <a:ext cx="292608" cy="292608"/>
-          </a:xfrm>
-          <a:prstGeom prst="rect">
-            <a:avLst/>
-          </a:prstGeom>
-          <a:noFill/>
-          <a:ln/>
-        </p:spPr>
-        <p:txBody>
-          <a:bodyPr wrap="square" lIns="0" tIns="0" rIns="0" bIns="0" rtlCol="0" anchor="ctr"/>
-          <a:lstStyle/>
-          <a:p>
-            <a:pPr algn="ctr" indent="0" marL="0">
-              <a:buNone/>
-            </a:pPr>
-            <a:r>
-              <a:rPr lang="en-US" sz="1300" b="1" dirty="0">
-                <a:solidFill>
-                  <a:srgbClr val="FFFFFF"/>
-                </a:solidFill>
-                <a:latin typeface="Calibri" pitchFamily="34" charset="0"/>
-                <a:ea typeface="Calibri" pitchFamily="34" charset="-122"/>
-                <a:cs typeface="Calibri" pitchFamily="34" charset="-120"/>
-              </a:rPr>
-              <a:t>!</a:t>
-            </a:r>
-            <a:endParaRPr lang="en-US" sz="1300" dirty="0"/>
-          </a:p>
-        </p:txBody>
-      </p:sp>
-      <p:sp>
-        <p:nvSpPr>
-          <p:cNvPr id="40" name="Text 38"/>
-          <p:cNvSpPr/>
-          <p:nvPr/>
-        </p:nvSpPr>
-        <p:spPr>
-          <a:xfrm>
-            <a:off x="1243584" y="5161788"/>
-            <a:ext cx="10058400" cy="438912"/>
-          </a:xfrm>
-          <a:prstGeom prst="rect">
-            <a:avLst/>
-          </a:prstGeom>
-          <a:noFill/>
-          <a:ln/>
-        </p:spPr>
-        <p:txBody>
-          <a:bodyPr wrap="square" lIns="0" tIns="0" rIns="0" bIns="0" rtlCol="0" anchor="t"/>
-          <a:lstStyle/>
-          <a:p>
-            <a:pPr indent="0" marL="0">
-              <a:lnSpc>
-                <a:spcPts val="1200"/>
-              </a:lnSpc>
-              <a:buNone/>
-            </a:pPr>
-            <a:r>
-              <a:rPr lang="en-US" sz="1000" dirty="0">
-                <a:solidFill>
-                  <a:srgbClr val="B4B7BD"/>
-                </a:solidFill>
-                <a:latin typeface="Calibri" pitchFamily="34" charset="0"/>
-                <a:ea typeface="Calibri" pitchFamily="34" charset="-122"/>
-                <a:cs typeface="Calibri" pitchFamily="34" charset="-120"/>
-              </a:rPr>
-              <a:t>Re-run this after any change to the response playbook. If a run ever completes without stopping for approval, stop and investigate before using the pack in production.</a:t>
-            </a:r>
-            <a:endParaRPr lang="en-US" sz="1000" dirty="0"/>
-          </a:p>
-        </p:txBody>
-      </p:sp>
     </p:spTree>
   </p:cSld>
   <p:clrMapOvr>
@@ -5286,141 +5062,6 @@
           </a:p>
         </p:txBody>
       </p:sp>
-      <p:sp>
-        <p:nvSpPr>
-          <p:cNvPr id="35" name="Shape 33"/>
-          <p:cNvSpPr/>
-          <p:nvPr/>
-        </p:nvSpPr>
-        <p:spPr>
-          <a:xfrm>
-            <a:off x="548640" y="4910328"/>
-            <a:ext cx="11064240" cy="658368"/>
-          </a:xfrm>
-          <a:prstGeom prst="roundRect">
-            <a:avLst>
-              <a:gd name="adj" fmla="val 6944"/>
-            </a:avLst>
-          </a:prstGeom>
-          <a:solidFill>
-            <a:srgbClr val="1C2026"/>
-          </a:solidFill>
-          <a:ln w="12700">
-            <a:solidFill>
-              <a:srgbClr val="1C2026"/>
-            </a:solidFill>
-            <a:prstDash val="solid"/>
-          </a:ln>
-        </p:spPr>
-      </p:sp>
-      <p:sp>
-        <p:nvSpPr>
-          <p:cNvPr id="36" name="Shape 34"/>
-          <p:cNvSpPr/>
-          <p:nvPr/>
-        </p:nvSpPr>
-        <p:spPr>
-          <a:xfrm>
-            <a:off x="786384" y="5093208"/>
-            <a:ext cx="292608" cy="292608"/>
-          </a:xfrm>
-          <a:prstGeom prst="roundRect">
-            <a:avLst>
-              <a:gd name="adj" fmla="val 28125"/>
-            </a:avLst>
-          </a:prstGeom>
-          <a:solidFill>
-            <a:srgbClr val="F5A524"/>
-          </a:solidFill>
-          <a:ln w="12700">
-            <a:solidFill>
-              <a:srgbClr val="F5A524"/>
-            </a:solidFill>
-            <a:prstDash val="solid"/>
-          </a:ln>
-        </p:spPr>
-      </p:sp>
-      <p:sp>
-        <p:nvSpPr>
-          <p:cNvPr id="37" name="Text 35"/>
-          <p:cNvSpPr/>
-          <p:nvPr/>
-        </p:nvSpPr>
-        <p:spPr>
-          <a:xfrm>
-            <a:off x="786384" y="5093208"/>
-            <a:ext cx="292608" cy="292608"/>
-          </a:xfrm>
-          <a:prstGeom prst="rect">
-            <a:avLst/>
-          </a:prstGeom>
-          <a:noFill/>
-          <a:ln/>
-        </p:spPr>
-        <p:txBody>
-          <a:bodyPr wrap="square" lIns="0" tIns="0" rIns="0" bIns="0" rtlCol="0" anchor="ctr"/>
-          <a:lstStyle/>
-          <a:p>
-            <a:pPr algn="ctr" indent="0" marL="0">
-              <a:buNone/>
-            </a:pPr>
-            <a:r>
-              <a:rPr lang="en-US" sz="1300" b="1" dirty="0">
-                <a:solidFill>
-                  <a:srgbClr val="FFFFFF"/>
-                </a:solidFill>
-                <a:latin typeface="Calibri" pitchFamily="34" charset="0"/>
-                <a:ea typeface="Calibri" pitchFamily="34" charset="-122"/>
-                <a:cs typeface="Calibri" pitchFamily="34" charset="-120"/>
-              </a:rPr>
-              <a:t>!</a:t>
-            </a:r>
-            <a:endParaRPr lang="en-US" sz="1300" dirty="0"/>
-          </a:p>
-        </p:txBody>
-      </p:sp>
-      <p:sp>
-        <p:nvSpPr>
-          <p:cNvPr id="38" name="Text 36"/>
-          <p:cNvSpPr/>
-          <p:nvPr/>
-        </p:nvSpPr>
-        <p:spPr>
-          <a:xfrm>
-            <a:off x="1243584" y="5020056"/>
-            <a:ext cx="10058400" cy="438912"/>
-          </a:xfrm>
-          <a:prstGeom prst="rect">
-            <a:avLst/>
-          </a:prstGeom>
-          <a:noFill/>
-          <a:ln/>
-        </p:spPr>
-        <p:txBody>
-          <a:bodyPr wrap="square" lIns="0" tIns="0" rIns="0" bIns="0" rtlCol="0" anchor="t"/>
-          <a:lstStyle/>
-          <a:p>
-            <a:pPr indent="0" marL="0">
-              <a:lnSpc>
-                <a:spcPts val="1200"/>
-              </a:lnSpc>
-              <a:buNone/>
-            </a:pPr>
-            <a:r>
-              <a:rPr lang="en-US" sz="1000" dirty="0">
-                <a:solidFill>
-                  <a:srgbClr val="B4B7BD"/>
-                </a:solidFill>
-                <a:latin typeface="Calibri" pitchFamily="34" charset="0"/>
-                <a:ea typeface="Calibri" pitchFamily="34" charset="-122"/>
-                <a:cs typeface="Calibri" pitchFamily="34" charset="-120"/>
-              </a:rPr>
-              <a:t>The sweep checks the XQL engine is answering before it runs, and stops cleanly if not. On XSIAM the engine is provisioned by the platform, so that check should simply pass.</a:t>
-            </a:r>
-            <a:endParaRPr lang="en-US" sz="1000" dirty="0"/>
-          </a:p>
-        </p:txBody>
-      </p:sp>
     </p:spTree>
   </p:cSld>
   <p:clrMapOvr>
@@ -6293,11 +5934,11 @@
         <p:spPr>
           <a:xfrm>
             <a:off x="548640" y="3232404"/>
-            <a:ext cx="6400800" cy="2656332"/>
+            <a:ext cx="6400800" cy="3351276"/>
           </a:xfrm>
           <a:prstGeom prst="roundRect">
             <a:avLst>
-              <a:gd name="adj" fmla="val 1721"/>
+              <a:gd name="adj" fmla="val 1364"/>
             </a:avLst>
           </a:prstGeom>
           <a:solidFill>
@@ -6764,11 +6405,11 @@
         <p:spPr>
           <a:xfrm>
             <a:off x="7315200" y="3232404"/>
-            <a:ext cx="4297680" cy="2656332"/>
+            <a:ext cx="4297680" cy="3351276"/>
           </a:xfrm>
           <a:prstGeom prst="roundRect">
             <a:avLst>
-              <a:gd name="adj" fmla="val 1721"/>
+              <a:gd name="adj" fmla="val 1364"/>
             </a:avLst>
           </a:prstGeom>
           <a:solidFill>
@@ -7061,141 +6702,6 @@
               <a:t>Re-running adds new endpoints without disturbing existing rows.</a:t>
             </a:r>
             <a:endParaRPr lang="en-US" sz="1150" dirty="0"/>
-          </a:p>
-        </p:txBody>
-      </p:sp>
-      <p:sp>
-        <p:nvSpPr>
-          <p:cNvPr id="43" name="Shape 41"/>
-          <p:cNvSpPr/>
-          <p:nvPr/>
-        </p:nvSpPr>
-        <p:spPr>
-          <a:xfrm>
-            <a:off x="548640" y="6016752"/>
-            <a:ext cx="11064240" cy="658368"/>
-          </a:xfrm>
-          <a:prstGeom prst="roundRect">
-            <a:avLst>
-              <a:gd name="adj" fmla="val 6944"/>
-            </a:avLst>
-          </a:prstGeom>
-          <a:solidFill>
-            <a:srgbClr val="1C2026"/>
-          </a:solidFill>
-          <a:ln w="12700">
-            <a:solidFill>
-              <a:srgbClr val="1C2026"/>
-            </a:solidFill>
-            <a:prstDash val="solid"/>
-          </a:ln>
-        </p:spPr>
-      </p:sp>
-      <p:sp>
-        <p:nvSpPr>
-          <p:cNvPr id="44" name="Shape 42"/>
-          <p:cNvSpPr/>
-          <p:nvPr/>
-        </p:nvSpPr>
-        <p:spPr>
-          <a:xfrm>
-            <a:off x="786384" y="6199632"/>
-            <a:ext cx="292608" cy="292608"/>
-          </a:xfrm>
-          <a:prstGeom prst="roundRect">
-            <a:avLst>
-              <a:gd name="adj" fmla="val 28125"/>
-            </a:avLst>
-          </a:prstGeom>
-          <a:solidFill>
-            <a:srgbClr val="F5A524"/>
-          </a:solidFill>
-          <a:ln w="12700">
-            <a:solidFill>
-              <a:srgbClr val="F5A524"/>
-            </a:solidFill>
-            <a:prstDash val="solid"/>
-          </a:ln>
-        </p:spPr>
-      </p:sp>
-      <p:sp>
-        <p:nvSpPr>
-          <p:cNvPr id="45" name="Text 43"/>
-          <p:cNvSpPr/>
-          <p:nvPr/>
-        </p:nvSpPr>
-        <p:spPr>
-          <a:xfrm>
-            <a:off x="786384" y="6199632"/>
-            <a:ext cx="292608" cy="292608"/>
-          </a:xfrm>
-          <a:prstGeom prst="rect">
-            <a:avLst/>
-          </a:prstGeom>
-          <a:noFill/>
-          <a:ln/>
-        </p:spPr>
-        <p:txBody>
-          <a:bodyPr wrap="square" lIns="0" tIns="0" rIns="0" bIns="0" rtlCol="0" anchor="ctr"/>
-          <a:lstStyle/>
-          <a:p>
-            <a:pPr algn="ctr" indent="0" marL="0">
-              <a:buNone/>
-            </a:pPr>
-            <a:r>
-              <a:rPr lang="en-US" sz="1300" b="1" dirty="0">
-                <a:solidFill>
-                  <a:srgbClr val="FFFFFF"/>
-                </a:solidFill>
-                <a:latin typeface="Calibri" pitchFamily="34" charset="0"/>
-                <a:ea typeface="Calibri" pitchFamily="34" charset="-122"/>
-                <a:cs typeface="Calibri" pitchFamily="34" charset="-120"/>
-              </a:rPr>
-              <a:t>!</a:t>
-            </a:r>
-            <a:endParaRPr lang="en-US" sz="1300" dirty="0"/>
-          </a:p>
-        </p:txBody>
-      </p:sp>
-      <p:sp>
-        <p:nvSpPr>
-          <p:cNvPr id="46" name="Text 44"/>
-          <p:cNvSpPr/>
-          <p:nvPr/>
-        </p:nvSpPr>
-        <p:spPr>
-          <a:xfrm>
-            <a:off x="1243584" y="6126480"/>
-            <a:ext cx="10058400" cy="438912"/>
-          </a:xfrm>
-          <a:prstGeom prst="rect">
-            <a:avLst/>
-          </a:prstGeom>
-          <a:noFill/>
-          <a:ln/>
-        </p:spPr>
-        <p:txBody>
-          <a:bodyPr wrap="square" lIns="0" tIns="0" rIns="0" bIns="0" rtlCol="0" anchor="t"/>
-          <a:lstStyle/>
-          <a:p>
-            <a:pPr indent="0" marL="0">
-              <a:lnSpc>
-                <a:spcPts val="1200"/>
-              </a:lnSpc>
-              <a:buNone/>
-            </a:pPr>
-            <a:r>
-              <a:rPr lang="en-US" sz="1000" dirty="0">
-                <a:solidFill>
-                  <a:srgbClr val="B4B7BD"/>
-                </a:solidFill>
-                <a:latin typeface="Calibri" pitchFamily="34" charset="0"/>
-                <a:ea typeface="Calibri" pitchFamily="34" charset="-122"/>
-                <a:cs typeface="Calibri" pitchFamily="34" charset="-120"/>
-              </a:rPr>
-              <a:t>Without a Core REST API instance this test cannot pass — the refresh reads endpoint groups through it, and the tracker simply stays empty.</a:t>
-            </a:r>
-            <a:endParaRPr lang="en-US" sz="1000" dirty="0"/>
           </a:p>
         </p:txBody>
       </p:sp>
@@ -7909,11 +7415,11 @@
         <p:spPr>
           <a:xfrm>
             <a:off x="548640" y="2670048"/>
-            <a:ext cx="6400800" cy="2852928"/>
+            <a:ext cx="6400800" cy="3557016"/>
           </a:xfrm>
           <a:prstGeom prst="roundRect">
             <a:avLst>
-              <a:gd name="adj" fmla="val 1603"/>
+              <a:gd name="adj" fmla="val 1285"/>
             </a:avLst>
           </a:prstGeom>
           <a:solidFill>
@@ -8299,11 +7805,11 @@
         <p:spPr>
           <a:xfrm>
             <a:off x="7315200" y="2670048"/>
-            <a:ext cx="4297680" cy="2852928"/>
+            <a:ext cx="4297680" cy="3557016"/>
           </a:xfrm>
           <a:prstGeom prst="roundRect">
             <a:avLst>
-              <a:gd name="adj" fmla="val 1603"/>
+              <a:gd name="adj" fmla="val 1285"/>
             </a:avLst>
           </a:prstGeom>
           <a:solidFill>
@@ -8682,107 +8188,53 @@
       </p:sp>
       <p:sp>
         <p:nvSpPr>
-          <p:cNvPr id="39" name="Shape 37"/>
-          <p:cNvSpPr/>
-          <p:nvPr/>
-        </p:nvSpPr>
-        <p:spPr>
-          <a:xfrm>
-            <a:off x="548640" y="5650992"/>
-            <a:ext cx="11064240" cy="658368"/>
-          </a:xfrm>
-          <a:prstGeom prst="roundRect">
-            <a:avLst>
-              <a:gd name="adj" fmla="val 6944"/>
-            </a:avLst>
-          </a:prstGeom>
-          <a:solidFill>
-            <a:srgbClr val="1C2026"/>
-          </a:solidFill>
-          <a:ln w="12700">
-            <a:solidFill>
-              <a:srgbClr val="1C2026"/>
-            </a:solidFill>
-            <a:prstDash val="solid"/>
-          </a:ln>
-        </p:spPr>
-      </p:sp>
-      <p:sp>
-        <p:nvSpPr>
-          <p:cNvPr id="40" name="Shape 38"/>
-          <p:cNvSpPr/>
-          <p:nvPr/>
-        </p:nvSpPr>
-        <p:spPr>
-          <a:xfrm>
-            <a:off x="786384" y="5833872"/>
-            <a:ext cx="292608" cy="292608"/>
-          </a:xfrm>
-          <a:prstGeom prst="roundRect">
-            <a:avLst>
-              <a:gd name="adj" fmla="val 28125"/>
-            </a:avLst>
-          </a:prstGeom>
-          <a:solidFill>
-            <a:srgbClr val="F5A524"/>
-          </a:solidFill>
-          <a:ln w="12700">
-            <a:solidFill>
-              <a:srgbClr val="F5A524"/>
-            </a:solidFill>
-            <a:prstDash val="solid"/>
-          </a:ln>
-        </p:spPr>
-      </p:sp>
-      <p:sp>
-        <p:nvSpPr>
-          <p:cNvPr id="41" name="Text 39"/>
-          <p:cNvSpPr/>
-          <p:nvPr/>
-        </p:nvSpPr>
-        <p:spPr>
-          <a:xfrm>
-            <a:off x="786384" y="5833872"/>
-            <a:ext cx="292608" cy="292608"/>
-          </a:xfrm>
-          <a:prstGeom prst="rect">
-            <a:avLst/>
-          </a:prstGeom>
-          <a:noFill/>
-          <a:ln/>
-        </p:spPr>
-        <p:txBody>
-          <a:bodyPr wrap="square" lIns="0" tIns="0" rIns="0" bIns="0" rtlCol="0" anchor="ctr"/>
-          <a:lstStyle/>
-          <a:p>
-            <a:pPr algn="ctr" indent="0" marL="0">
-              <a:buNone/>
-            </a:pPr>
-            <a:r>
-              <a:rPr lang="en-US" sz="1300" b="1" dirty="0">
-                <a:solidFill>
-                  <a:srgbClr val="FFFFFF"/>
-                </a:solidFill>
-                <a:latin typeface="Calibri" pitchFamily="34" charset="0"/>
-                <a:ea typeface="Calibri" pitchFamily="34" charset="-122"/>
-                <a:cs typeface="Calibri" pitchFamily="34" charset="-120"/>
-              </a:rPr>
-              <a:t>!</a:t>
-            </a:r>
-            <a:endParaRPr lang="en-US" sz="1300" dirty="0"/>
-          </a:p>
-        </p:txBody>
-      </p:sp>
-      <p:sp>
-        <p:nvSpPr>
-          <p:cNvPr id="42" name="Text 40"/>
-          <p:cNvSpPr/>
-          <p:nvPr/>
-        </p:nvSpPr>
-        <p:spPr>
-          <a:xfrm>
-            <a:off x="1243584" y="5760720"/>
-            <a:ext cx="10058400" cy="438912"/>
+          <p:cNvPr id="39" name="Text 37"/>
+          <p:cNvSpPr/>
+          <p:nvPr/>
+        </p:nvSpPr>
+        <p:spPr>
+          <a:xfrm>
+            <a:off x="7626096" y="5266944"/>
+            <a:ext cx="219456" cy="256032"/>
+          </a:xfrm>
+          <a:prstGeom prst="rect">
+            <a:avLst/>
+          </a:prstGeom>
+          <a:noFill/>
+          <a:ln/>
+        </p:spPr>
+        <p:txBody>
+          <a:bodyPr wrap="square" lIns="0" tIns="0" rIns="0" bIns="0" rtlCol="0" anchor="t"/>
+          <a:lstStyle/>
+          <a:p>
+            <a:pPr indent="0" marL="0">
+              <a:buNone/>
+            </a:pPr>
+            <a:r>
+              <a:rPr lang="en-US" sz="1150" b="1" dirty="0">
+                <a:solidFill>
+                  <a:srgbClr val="3FB950"/>
+                </a:solidFill>
+                <a:latin typeface="Calibri" pitchFamily="34" charset="0"/>
+                <a:ea typeface="Calibri" pitchFamily="34" charset="-122"/>
+                <a:cs typeface="Calibri" pitchFamily="34" charset="-120"/>
+              </a:rPr>
+              <a:t>✓</a:t>
+            </a:r>
+            <a:endParaRPr lang="en-US" sz="1150" dirty="0"/>
+          </a:p>
+        </p:txBody>
+      </p:sp>
+      <p:sp>
+        <p:nvSpPr>
+          <p:cNvPr id="40" name="Text 38"/>
+          <p:cNvSpPr/>
+          <p:nvPr/>
+        </p:nvSpPr>
+        <p:spPr>
+          <a:xfrm>
+            <a:off x="7918704" y="5266944"/>
+            <a:ext cx="3383280" cy="630936"/>
           </a:xfrm>
           <a:prstGeom prst="rect">
             <a:avLst/>
@@ -8796,12 +8248,12 @@
           <a:p>
             <a:pPr indent="0" marL="0">
               <a:lnSpc>
-                <a:spcPts val="1200"/>
+                <a:spcPts val="1500"/>
               </a:lnSpc>
               <a:buNone/>
             </a:pPr>
             <a:r>
-              <a:rPr lang="en-US" sz="1000" dirty="0">
+              <a:rPr lang="en-US" sz="1150" dirty="0">
                 <a:solidFill>
                   <a:srgbClr val="B4B7BD"/>
                 </a:solidFill>
@@ -8809,9 +8261,9 @@
                 <a:ea typeface="Calibri" pitchFamily="34" charset="-122"/>
                 <a:cs typeface="Calibri" pitchFamily="34" charset="-120"/>
               </a:rPr>
-              <a:t>SKIPPED means nothing is due right now and sends no email, by design. STILL RUNNING means the script was dispatched and Action Center is finishing on its own. Neither is a failure.</a:t>
-            </a:r>
-            <a:endParaRPr lang="en-US" sz="1000" dirty="0"/>
+              <a:t>A SKIPPED entry means nothing was due; a STILL RUNNING entry means Action Center is finishing on its own. Both are normal and send no email.</a:t>
+            </a:r>
+            <a:endParaRPr lang="en-US" sz="1150" dirty="0"/>
           </a:p>
         </p:txBody>
       </p:sp>
@@ -10053,141 +9505,6 @@
           </a:p>
         </p:txBody>
       </p:sp>
-      <p:sp>
-        <p:nvSpPr>
-          <p:cNvPr id="33" name="Shape 31"/>
-          <p:cNvSpPr/>
-          <p:nvPr/>
-        </p:nvSpPr>
-        <p:spPr>
-          <a:xfrm>
-            <a:off x="548640" y="4910328"/>
-            <a:ext cx="11064240" cy="658368"/>
-          </a:xfrm>
-          <a:prstGeom prst="roundRect">
-            <a:avLst>
-              <a:gd name="adj" fmla="val 6944"/>
-            </a:avLst>
-          </a:prstGeom>
-          <a:solidFill>
-            <a:srgbClr val="1C2026"/>
-          </a:solidFill>
-          <a:ln w="12700">
-            <a:solidFill>
-              <a:srgbClr val="1C2026"/>
-            </a:solidFill>
-            <a:prstDash val="solid"/>
-          </a:ln>
-        </p:spPr>
-      </p:sp>
-      <p:sp>
-        <p:nvSpPr>
-          <p:cNvPr id="34" name="Shape 32"/>
-          <p:cNvSpPr/>
-          <p:nvPr/>
-        </p:nvSpPr>
-        <p:spPr>
-          <a:xfrm>
-            <a:off x="786384" y="5093208"/>
-            <a:ext cx="292608" cy="292608"/>
-          </a:xfrm>
-          <a:prstGeom prst="roundRect">
-            <a:avLst>
-              <a:gd name="adj" fmla="val 28125"/>
-            </a:avLst>
-          </a:prstGeom>
-          <a:solidFill>
-            <a:srgbClr val="F5A524"/>
-          </a:solidFill>
-          <a:ln w="12700">
-            <a:solidFill>
-              <a:srgbClr val="F5A524"/>
-            </a:solidFill>
-            <a:prstDash val="solid"/>
-          </a:ln>
-        </p:spPr>
-      </p:sp>
-      <p:sp>
-        <p:nvSpPr>
-          <p:cNvPr id="35" name="Text 33"/>
-          <p:cNvSpPr/>
-          <p:nvPr/>
-        </p:nvSpPr>
-        <p:spPr>
-          <a:xfrm>
-            <a:off x="786384" y="5093208"/>
-            <a:ext cx="292608" cy="292608"/>
-          </a:xfrm>
-          <a:prstGeom prst="rect">
-            <a:avLst/>
-          </a:prstGeom>
-          <a:noFill/>
-          <a:ln/>
-        </p:spPr>
-        <p:txBody>
-          <a:bodyPr wrap="square" lIns="0" tIns="0" rIns="0" bIns="0" rtlCol="0" anchor="ctr"/>
-          <a:lstStyle/>
-          <a:p>
-            <a:pPr algn="ctr" indent="0" marL="0">
-              <a:buNone/>
-            </a:pPr>
-            <a:r>
-              <a:rPr lang="en-US" sz="1300" b="1" dirty="0">
-                <a:solidFill>
-                  <a:srgbClr val="FFFFFF"/>
-                </a:solidFill>
-                <a:latin typeface="Calibri" pitchFamily="34" charset="0"/>
-                <a:ea typeface="Calibri" pitchFamily="34" charset="-122"/>
-                <a:cs typeface="Calibri" pitchFamily="34" charset="-120"/>
-              </a:rPr>
-              <a:t>!</a:t>
-            </a:r>
-            <a:endParaRPr lang="en-US" sz="1300" dirty="0"/>
-          </a:p>
-        </p:txBody>
-      </p:sp>
-      <p:sp>
-        <p:nvSpPr>
-          <p:cNvPr id="36" name="Text 34"/>
-          <p:cNvSpPr/>
-          <p:nvPr/>
-        </p:nvSpPr>
-        <p:spPr>
-          <a:xfrm>
-            <a:off x="1243584" y="5020056"/>
-            <a:ext cx="10058400" cy="438912"/>
-          </a:xfrm>
-          <a:prstGeom prst="rect">
-            <a:avLst/>
-          </a:prstGeom>
-          <a:noFill/>
-          <a:ln/>
-        </p:spPr>
-        <p:txBody>
-          <a:bodyPr wrap="square" lIns="0" tIns="0" rIns="0" bIns="0" rtlCol="0" anchor="t"/>
-          <a:lstStyle/>
-          <a:p>
-            <a:pPr indent="0" marL="0">
-              <a:lnSpc>
-                <a:spcPts val="1200"/>
-              </a:lnSpc>
-              <a:buNone/>
-            </a:pPr>
-            <a:r>
-              <a:rPr lang="en-US" sz="1000" dirty="0">
-                <a:solidFill>
-                  <a:srgbClr val="B4B7BD"/>
-                </a:solidFill>
-                <a:latin typeface="Calibri" pitchFamily="34" charset="0"/>
-                <a:ea typeface="Calibri" pitchFamily="34" charset="-122"/>
-                <a:cs typeface="Calibri" pitchFamily="34" charset="-120"/>
-              </a:rPr>
-              <a:t>This is what the extension adds over the Marketplace pack alone. If fields are empty, triage has not run on that alert yet — it is triage that writes them.</a:t>
-            </a:r>
-            <a:endParaRPr lang="en-US" sz="1000" dirty="0"/>
-          </a:p>
-        </p:txBody>
-      </p:sp>
     </p:spTree>
   </p:cSld>
   <p:clrMapOvr>
@@ -10222,1307 +9539,6 @@
       </p:grpSpPr>
       <p:sp>
         <p:nvSpPr>
-          <p:cNvPr id="2" name="Text 0"/>
-          <p:cNvSpPr/>
-          <p:nvPr/>
-        </p:nvSpPr>
-        <p:spPr>
-          <a:xfrm>
-            <a:off x="548640" y="384048"/>
-            <a:ext cx="11064240" cy="237744"/>
-          </a:xfrm>
-          <a:prstGeom prst="rect">
-            <a:avLst/>
-          </a:prstGeom>
-          <a:noFill/>
-          <a:ln/>
-        </p:spPr>
-        <p:txBody>
-          <a:bodyPr wrap="square" lIns="0" tIns="0" rIns="0" bIns="0" rtlCol="0" anchor="t"/>
-          <a:lstStyle/>
-          <a:p>
-            <a:pPr indent="0" marL="0">
-              <a:buNone/>
-            </a:pPr>
-            <a:r>
-              <a:rPr lang="en-US" sz="1100" b="1" spc="200" kern="0" dirty="0">
-                <a:solidFill>
-                  <a:srgbClr val="E8551F"/>
-                </a:solidFill>
-                <a:latin typeface="Calibri" pitchFamily="34" charset="0"/>
-                <a:ea typeface="Calibri" pitchFamily="34" charset="-122"/>
-                <a:cs typeface="Calibri" pitchFamily="34" charset="-120"/>
-              </a:rPr>
-              <a:t>IF SOMETHING FAILS</a:t>
-            </a:r>
-            <a:endParaRPr lang="en-US" sz="1100" dirty="0"/>
-          </a:p>
-        </p:txBody>
-      </p:sp>
-      <p:sp>
-        <p:nvSpPr>
-          <p:cNvPr id="3" name="Text 1"/>
-          <p:cNvSpPr/>
-          <p:nvPr/>
-        </p:nvSpPr>
-        <p:spPr>
-          <a:xfrm>
-            <a:off x="548640" y="640080"/>
-            <a:ext cx="11064240" cy="640080"/>
-          </a:xfrm>
-          <a:prstGeom prst="rect">
-            <a:avLst/>
-          </a:prstGeom>
-          <a:noFill/>
-          <a:ln/>
-        </p:spPr>
-        <p:txBody>
-          <a:bodyPr wrap="square" lIns="0" tIns="0" rIns="0" bIns="0" rtlCol="0" anchor="t"/>
-          <a:lstStyle/>
-          <a:p>
-            <a:pPr indent="0" marL="0">
-              <a:buNone/>
-            </a:pPr>
-            <a:r>
-              <a:rPr lang="en-US" sz="3100" b="1" dirty="0">
-                <a:solidFill>
-                  <a:srgbClr val="FFFFFF"/>
-                </a:solidFill>
-                <a:latin typeface="Calibri" pitchFamily="34" charset="0"/>
-                <a:ea typeface="Calibri" pitchFamily="34" charset="-122"/>
-                <a:cs typeface="Calibri" pitchFamily="34" charset="-120"/>
-              </a:rPr>
-              <a:t>Check the prerequisite before the product</a:t>
-            </a:r>
-            <a:endParaRPr lang="en-US" sz="3100" dirty="0"/>
-          </a:p>
-        </p:txBody>
-      </p:sp>
-      <p:sp>
-        <p:nvSpPr>
-          <p:cNvPr id="4" name="Shape 2"/>
-          <p:cNvSpPr/>
-          <p:nvPr/>
-        </p:nvSpPr>
-        <p:spPr>
-          <a:xfrm>
-            <a:off x="548640" y="1371600"/>
-            <a:ext cx="11064240" cy="457200"/>
-          </a:xfrm>
-          <a:prstGeom prst="roundRect">
-            <a:avLst>
-              <a:gd name="adj" fmla="val 10000"/>
-            </a:avLst>
-          </a:prstGeom>
-          <a:solidFill>
-            <a:srgbClr val="15171B"/>
-          </a:solidFill>
-          <a:ln w="12700">
-            <a:solidFill>
-              <a:srgbClr val="15171B"/>
-            </a:solidFill>
-            <a:prstDash val="solid"/>
-          </a:ln>
-        </p:spPr>
-      </p:sp>
-      <p:sp>
-        <p:nvSpPr>
-          <p:cNvPr id="5" name="Text 3"/>
-          <p:cNvSpPr/>
-          <p:nvPr/>
-        </p:nvSpPr>
-        <p:spPr>
-          <a:xfrm>
-            <a:off x="822960" y="1499616"/>
-            <a:ext cx="3017520" cy="237744"/>
-          </a:xfrm>
-          <a:prstGeom prst="rect">
-            <a:avLst/>
-          </a:prstGeom>
-          <a:noFill/>
-          <a:ln/>
-        </p:spPr>
-        <p:txBody>
-          <a:bodyPr wrap="square" lIns="0" tIns="0" rIns="0" bIns="0" rtlCol="0" anchor="t"/>
-          <a:lstStyle/>
-          <a:p>
-            <a:pPr indent="0" marL="0">
-              <a:buNone/>
-            </a:pPr>
-            <a:r>
-              <a:rPr lang="en-US" sz="1100" b="1" dirty="0">
-                <a:solidFill>
-                  <a:srgbClr val="FFFFFF"/>
-                </a:solidFill>
-                <a:latin typeface="Calibri" pitchFamily="34" charset="0"/>
-                <a:ea typeface="Calibri" pitchFamily="34" charset="-122"/>
-                <a:cs typeface="Calibri" pitchFamily="34" charset="-120"/>
-              </a:rPr>
-              <a:t>Integration not offered</a:t>
-            </a:r>
-            <a:endParaRPr lang="en-US" sz="1100" dirty="0"/>
-          </a:p>
-        </p:txBody>
-      </p:sp>
-      <p:sp>
-        <p:nvSpPr>
-          <p:cNvPr id="6" name="Text 4"/>
-          <p:cNvSpPr/>
-          <p:nvPr/>
-        </p:nvSpPr>
-        <p:spPr>
-          <a:xfrm>
-            <a:off x="4023360" y="1508760"/>
-            <a:ext cx="3108960" cy="237744"/>
-          </a:xfrm>
-          <a:prstGeom prst="rect">
-            <a:avLst/>
-          </a:prstGeom>
-          <a:noFill/>
-          <a:ln/>
-        </p:spPr>
-        <p:txBody>
-          <a:bodyPr wrap="square" lIns="0" tIns="0" rIns="0" bIns="0" rtlCol="0" anchor="t"/>
-          <a:lstStyle/>
-          <a:p>
-            <a:pPr indent="0" marL="0">
-              <a:buNone/>
-            </a:pPr>
-            <a:r>
-              <a:rPr lang="en-US" sz="1000" dirty="0">
-                <a:solidFill>
-                  <a:srgbClr val="F5A524"/>
-                </a:solidFill>
-                <a:latin typeface="Calibri" pitchFamily="34" charset="0"/>
-                <a:ea typeface="Calibri" pitchFamily="34" charset="-122"/>
-                <a:cs typeface="Calibri" pitchFamily="34" charset="-120"/>
-              </a:rPr>
-              <a:t>Marketplace KOI pack not installed</a:t>
-            </a:r>
-            <a:endParaRPr lang="en-US" sz="1000" dirty="0"/>
-          </a:p>
-        </p:txBody>
-      </p:sp>
-      <p:sp>
-        <p:nvSpPr>
-          <p:cNvPr id="7" name="Text 5"/>
-          <p:cNvSpPr/>
-          <p:nvPr/>
-        </p:nvSpPr>
-        <p:spPr>
-          <a:xfrm>
-            <a:off x="7315200" y="1508760"/>
-            <a:ext cx="4023360" cy="237744"/>
-          </a:xfrm>
-          <a:prstGeom prst="rect">
-            <a:avLst/>
-          </a:prstGeom>
-          <a:noFill/>
-          <a:ln/>
-        </p:spPr>
-        <p:txBody>
-          <a:bodyPr wrap="square" lIns="0" tIns="0" rIns="0" bIns="0" rtlCol="0" anchor="t"/>
-          <a:lstStyle/>
-          <a:p>
-            <a:pPr indent="0" marL="0">
-              <a:buNone/>
-            </a:pPr>
-            <a:r>
-              <a:rPr lang="en-US" sz="1000" dirty="0">
-                <a:solidFill>
-                  <a:srgbClr val="B4B7BD"/>
-                </a:solidFill>
-                <a:latin typeface="Calibri" pitchFamily="34" charset="0"/>
-                <a:ea typeface="Calibri" pitchFamily="34" charset="-122"/>
-                <a:cs typeface="Calibri" pitchFamily="34" charset="-120"/>
-              </a:rPr>
-              <a:t>Install it first — this extension ships no integration</a:t>
-            </a:r>
-            <a:endParaRPr lang="en-US" sz="1000" dirty="0"/>
-          </a:p>
-        </p:txBody>
-      </p:sp>
-      <p:sp>
-        <p:nvSpPr>
-          <p:cNvPr id="8" name="Shape 6"/>
-          <p:cNvSpPr/>
-          <p:nvPr/>
-        </p:nvSpPr>
-        <p:spPr>
-          <a:xfrm>
-            <a:off x="548640" y="1929384"/>
-            <a:ext cx="11064240" cy="457200"/>
-          </a:xfrm>
-          <a:prstGeom prst="roundRect">
-            <a:avLst>
-              <a:gd name="adj" fmla="val 10000"/>
-            </a:avLst>
-          </a:prstGeom>
-          <a:solidFill>
-            <a:srgbClr val="15171B"/>
-          </a:solidFill>
-          <a:ln w="12700">
-            <a:solidFill>
-              <a:srgbClr val="15171B"/>
-            </a:solidFill>
-            <a:prstDash val="solid"/>
-          </a:ln>
-        </p:spPr>
-      </p:sp>
-      <p:sp>
-        <p:nvSpPr>
-          <p:cNvPr id="9" name="Text 7"/>
-          <p:cNvSpPr/>
-          <p:nvPr/>
-        </p:nvSpPr>
-        <p:spPr>
-          <a:xfrm>
-            <a:off x="822960" y="2057400"/>
-            <a:ext cx="3017520" cy="237744"/>
-          </a:xfrm>
-          <a:prstGeom prst="rect">
-            <a:avLst/>
-          </a:prstGeom>
-          <a:noFill/>
-          <a:ln/>
-        </p:spPr>
-        <p:txBody>
-          <a:bodyPr wrap="square" lIns="0" tIns="0" rIns="0" bIns="0" rtlCol="0" anchor="t"/>
-          <a:lstStyle/>
-          <a:p>
-            <a:pPr indent="0" marL="0">
-              <a:buNone/>
-            </a:pPr>
-            <a:r>
-              <a:rPr lang="en-US" sz="1100" b="1" dirty="0">
-                <a:solidFill>
-                  <a:srgbClr val="FFFFFF"/>
-                </a:solidFill>
-                <a:latin typeface="Calibri" pitchFamily="34" charset="0"/>
-                <a:ea typeface="Calibri" pitchFamily="34" charset="-122"/>
-                <a:cs typeface="Calibri" pitchFamily="34" charset="-120"/>
-              </a:rPr>
-              <a:t>403 on KOI commands</a:t>
-            </a:r>
-            <a:endParaRPr lang="en-US" sz="1100" dirty="0"/>
-          </a:p>
-        </p:txBody>
-      </p:sp>
-      <p:sp>
-        <p:nvSpPr>
-          <p:cNvPr id="10" name="Text 8"/>
-          <p:cNvSpPr/>
-          <p:nvPr/>
-        </p:nvSpPr>
-        <p:spPr>
-          <a:xfrm>
-            <a:off x="4023360" y="2066544"/>
-            <a:ext cx="3108960" cy="237744"/>
-          </a:xfrm>
-          <a:prstGeom prst="rect">
-            <a:avLst/>
-          </a:prstGeom>
-          <a:noFill/>
-          <a:ln/>
-        </p:spPr>
-        <p:txBody>
-          <a:bodyPr wrap="square" lIns="0" tIns="0" rIns="0" bIns="0" rtlCol="0" anchor="t"/>
-          <a:lstStyle/>
-          <a:p>
-            <a:pPr indent="0" marL="0">
-              <a:buNone/>
-            </a:pPr>
-            <a:r>
-              <a:rPr lang="en-US" sz="1000" dirty="0">
-                <a:solidFill>
-                  <a:srgbClr val="F5A524"/>
-                </a:solidFill>
-                <a:latin typeface="Calibri" pitchFamily="34" charset="0"/>
-                <a:ea typeface="Calibri" pitchFamily="34" charset="-122"/>
-                <a:cs typeface="Calibri" pitchFamily="34" charset="-120"/>
-              </a:rPr>
-              <a:t>Source IP not accepted by KOI</a:t>
-            </a:r>
-            <a:endParaRPr lang="en-US" sz="1000" dirty="0"/>
-          </a:p>
-        </p:txBody>
-      </p:sp>
-      <p:sp>
-        <p:nvSpPr>
-          <p:cNvPr id="11" name="Text 9"/>
-          <p:cNvSpPr/>
-          <p:nvPr/>
-        </p:nvSpPr>
-        <p:spPr>
-          <a:xfrm>
-            <a:off x="7315200" y="2066544"/>
-            <a:ext cx="4023360" cy="237744"/>
-          </a:xfrm>
-          <a:prstGeom prst="rect">
-            <a:avLst/>
-          </a:prstGeom>
-          <a:noFill/>
-          <a:ln/>
-        </p:spPr>
-        <p:txBody>
-          <a:bodyPr wrap="square" lIns="0" tIns="0" rIns="0" bIns="0" rtlCol="0" anchor="t"/>
-          <a:lstStyle/>
-          <a:p>
-            <a:pPr indent="0" marL="0">
-              <a:buNone/>
-            </a:pPr>
-            <a:r>
-              <a:rPr lang="en-US" sz="1000" dirty="0">
-                <a:solidFill>
-                  <a:srgbClr val="B4B7BD"/>
-                </a:solidFill>
-                <a:latin typeface="Calibri" pitchFamily="34" charset="0"/>
-                <a:ea typeface="Calibri" pitchFamily="34" charset="-122"/>
-                <a:cs typeface="Calibri" pitchFamily="34" charset="-120"/>
-              </a:rPr>
-              <a:t>Run the instance on a Cortex engine KOI accepts</a:t>
-            </a:r>
-            <a:endParaRPr lang="en-US" sz="1000" dirty="0"/>
-          </a:p>
-        </p:txBody>
-      </p:sp>
-      <p:sp>
-        <p:nvSpPr>
-          <p:cNvPr id="12" name="Shape 10"/>
-          <p:cNvSpPr/>
-          <p:nvPr/>
-        </p:nvSpPr>
-        <p:spPr>
-          <a:xfrm>
-            <a:off x="548640" y="2487168"/>
-            <a:ext cx="11064240" cy="457200"/>
-          </a:xfrm>
-          <a:prstGeom prst="roundRect">
-            <a:avLst>
-              <a:gd name="adj" fmla="val 10000"/>
-            </a:avLst>
-          </a:prstGeom>
-          <a:solidFill>
-            <a:srgbClr val="15171B"/>
-          </a:solidFill>
-          <a:ln w="12700">
-            <a:solidFill>
-              <a:srgbClr val="15171B"/>
-            </a:solidFill>
-            <a:prstDash val="solid"/>
-          </a:ln>
-        </p:spPr>
-      </p:sp>
-      <p:sp>
-        <p:nvSpPr>
-          <p:cNvPr id="13" name="Text 11"/>
-          <p:cNvSpPr/>
-          <p:nvPr/>
-        </p:nvSpPr>
-        <p:spPr>
-          <a:xfrm>
-            <a:off x="822960" y="2615184"/>
-            <a:ext cx="3017520" cy="237744"/>
-          </a:xfrm>
-          <a:prstGeom prst="rect">
-            <a:avLst/>
-          </a:prstGeom>
-          <a:noFill/>
-          <a:ln/>
-        </p:spPr>
-        <p:txBody>
-          <a:bodyPr wrap="square" lIns="0" tIns="0" rIns="0" bIns="0" rtlCol="0" anchor="t"/>
-          <a:lstStyle/>
-          <a:p>
-            <a:pPr indent="0" marL="0">
-              <a:buNone/>
-            </a:pPr>
-            <a:r>
-              <a:rPr lang="en-US" sz="1100" b="1" dirty="0">
-                <a:solidFill>
-                  <a:srgbClr val="FFFFFF"/>
-                </a:solidFill>
-                <a:latin typeface="Calibri" pitchFamily="34" charset="0"/>
-                <a:ea typeface="Calibri" pitchFamily="34" charset="-122"/>
-                <a:cs typeface="Calibri" pitchFamily="34" charset="-120"/>
-              </a:rPr>
-              <a:t>Promoted fields missing</a:t>
-            </a:r>
-            <a:endParaRPr lang="en-US" sz="1100" dirty="0"/>
-          </a:p>
-        </p:txBody>
-      </p:sp>
-      <p:sp>
-        <p:nvSpPr>
-          <p:cNvPr id="14" name="Text 12"/>
-          <p:cNvSpPr/>
-          <p:nvPr/>
-        </p:nvSpPr>
-        <p:spPr>
-          <a:xfrm>
-            <a:off x="4023360" y="2624328"/>
-            <a:ext cx="3108960" cy="237744"/>
-          </a:xfrm>
-          <a:prstGeom prst="rect">
-            <a:avLst/>
-          </a:prstGeom>
-          <a:noFill/>
-          <a:ln/>
-        </p:spPr>
-        <p:txBody>
-          <a:bodyPr wrap="square" lIns="0" tIns="0" rIns="0" bIns="0" rtlCol="0" anchor="t"/>
-          <a:lstStyle/>
-          <a:p>
-            <a:pPr indent="0" marL="0">
-              <a:buNone/>
-            </a:pPr>
-            <a:r>
-              <a:rPr lang="en-US" sz="1000" dirty="0">
-                <a:solidFill>
-                  <a:srgbClr val="F5A524"/>
-                </a:solidFill>
-                <a:latin typeface="Calibri" pitchFamily="34" charset="0"/>
-                <a:ea typeface="Calibri" pitchFamily="34" charset="-122"/>
-                <a:cs typeface="Calibri" pitchFamily="34" charset="-120"/>
-              </a:rPr>
-              <a:t>This extension not installed or not active</a:t>
-            </a:r>
-            <a:endParaRPr lang="en-US" sz="1000" dirty="0"/>
-          </a:p>
-        </p:txBody>
-      </p:sp>
-      <p:sp>
-        <p:nvSpPr>
-          <p:cNvPr id="15" name="Text 13"/>
-          <p:cNvSpPr/>
-          <p:nvPr/>
-        </p:nvSpPr>
-        <p:spPr>
-          <a:xfrm>
-            <a:off x="7315200" y="2624328"/>
-            <a:ext cx="4023360" cy="237744"/>
-          </a:xfrm>
-          <a:prstGeom prst="rect">
-            <a:avLst/>
-          </a:prstGeom>
-          <a:noFill/>
-          <a:ln/>
-        </p:spPr>
-        <p:txBody>
-          <a:bodyPr wrap="square" lIns="0" tIns="0" rIns="0" bIns="0" rtlCol="0" anchor="t"/>
-          <a:lstStyle/>
-          <a:p>
-            <a:pPr indent="0" marL="0">
-              <a:buNone/>
-            </a:pPr>
-            <a:r>
-              <a:rPr lang="en-US" sz="1000" dirty="0">
-                <a:solidFill>
-                  <a:srgbClr val="B4B7BD"/>
-                </a:solidFill>
-                <a:latin typeface="Calibri" pitchFamily="34" charset="0"/>
-                <a:ea typeface="Calibri" pitchFamily="34" charset="-122"/>
-                <a:cs typeface="Calibri" pitchFamily="34" charset="-120"/>
-              </a:rPr>
-              <a:t>Re-check the pack installed and events arrived after it</a:t>
-            </a:r>
-            <a:endParaRPr lang="en-US" sz="1000" dirty="0"/>
-          </a:p>
-        </p:txBody>
-      </p:sp>
-      <p:sp>
-        <p:nvSpPr>
-          <p:cNvPr id="16" name="Shape 14"/>
-          <p:cNvSpPr/>
-          <p:nvPr/>
-        </p:nvSpPr>
-        <p:spPr>
-          <a:xfrm>
-            <a:off x="548640" y="3044952"/>
-            <a:ext cx="11064240" cy="457200"/>
-          </a:xfrm>
-          <a:prstGeom prst="roundRect">
-            <a:avLst>
-              <a:gd name="adj" fmla="val 10000"/>
-            </a:avLst>
-          </a:prstGeom>
-          <a:solidFill>
-            <a:srgbClr val="15171B"/>
-          </a:solidFill>
-          <a:ln w="12700">
-            <a:solidFill>
-              <a:srgbClr val="15171B"/>
-            </a:solidFill>
-            <a:prstDash val="solid"/>
-          </a:ln>
-        </p:spPr>
-      </p:sp>
-      <p:sp>
-        <p:nvSpPr>
-          <p:cNvPr id="17" name="Text 15"/>
-          <p:cNvSpPr/>
-          <p:nvPr/>
-        </p:nvSpPr>
-        <p:spPr>
-          <a:xfrm>
-            <a:off x="822960" y="3172968"/>
-            <a:ext cx="3017520" cy="237744"/>
-          </a:xfrm>
-          <a:prstGeom prst="rect">
-            <a:avLst/>
-          </a:prstGeom>
-          <a:noFill/>
-          <a:ln/>
-        </p:spPr>
-        <p:txBody>
-          <a:bodyPr wrap="square" lIns="0" tIns="0" rIns="0" bIns="0" rtlCol="0" anchor="t"/>
-          <a:lstStyle/>
-          <a:p>
-            <a:pPr indent="0" marL="0">
-              <a:buNone/>
-            </a:pPr>
-            <a:r>
-              <a:rPr lang="en-US" sz="1100" b="1" dirty="0">
-                <a:solidFill>
-                  <a:srgbClr val="FFFFFF"/>
-                </a:solidFill>
-                <a:latin typeface="Calibri" pitchFamily="34" charset="0"/>
-                <a:ea typeface="Calibri" pitchFamily="34" charset="-122"/>
-                <a:cs typeface="Calibri" pitchFamily="34" charset="-120"/>
-              </a:rPr>
-              <a:t>Everything triages Suspicious</a:t>
-            </a:r>
-            <a:endParaRPr lang="en-US" sz="1100" dirty="0"/>
-          </a:p>
-        </p:txBody>
-      </p:sp>
-      <p:sp>
-        <p:nvSpPr>
-          <p:cNvPr id="18" name="Text 16"/>
-          <p:cNvSpPr/>
-          <p:nvPr/>
-        </p:nvSpPr>
-        <p:spPr>
-          <a:xfrm>
-            <a:off x="4023360" y="3182112"/>
-            <a:ext cx="3108960" cy="237744"/>
-          </a:xfrm>
-          <a:prstGeom prst="rect">
-            <a:avLst/>
-          </a:prstGeom>
-          <a:noFill/>
-          <a:ln/>
-        </p:spPr>
-        <p:txBody>
-          <a:bodyPr wrap="square" lIns="0" tIns="0" rIns="0" bIns="0" rtlCol="0" anchor="t"/>
-          <a:lstStyle/>
-          <a:p>
-            <a:pPr indent="0" marL="0">
-              <a:buNone/>
-            </a:pPr>
-            <a:r>
-              <a:rPr lang="en-US" sz="1000" dirty="0">
-                <a:solidFill>
-                  <a:srgbClr val="F5A524"/>
-                </a:solidFill>
-                <a:latin typeface="Calibri" pitchFamily="34" charset="0"/>
-                <a:ea typeface="Calibri" pitchFamily="34" charset="-122"/>
-                <a:cs typeface="Calibri" pitchFamily="34" charset="-120"/>
-              </a:rPr>
-              <a:t>The alert carried no KOI detail</a:t>
-            </a:r>
-            <a:endParaRPr lang="en-US" sz="1000" dirty="0"/>
-          </a:p>
-        </p:txBody>
-      </p:sp>
-      <p:sp>
-        <p:nvSpPr>
-          <p:cNvPr id="19" name="Text 17"/>
-          <p:cNvSpPr/>
-          <p:nvPr/>
-        </p:nvSpPr>
-        <p:spPr>
-          <a:xfrm>
-            <a:off x="7315200" y="3182112"/>
-            <a:ext cx="4023360" cy="237744"/>
-          </a:xfrm>
-          <a:prstGeom prst="rect">
-            <a:avLst/>
-          </a:prstGeom>
-          <a:noFill/>
-          <a:ln/>
-        </p:spPr>
-        <p:txBody>
-          <a:bodyPr wrap="square" lIns="0" tIns="0" rIns="0" bIns="0" rtlCol="0" anchor="t"/>
-          <a:lstStyle/>
-          <a:p>
-            <a:pPr indent="0" marL="0">
-              <a:buNone/>
-            </a:pPr>
-            <a:r>
-              <a:rPr lang="en-US" sz="1000" dirty="0">
-                <a:solidFill>
-                  <a:srgbClr val="B4B7BD"/>
-                </a:solidFill>
-                <a:latin typeface="Calibri" pitchFamily="34" charset="0"/>
-                <a:ea typeface="Calibri" pitchFamily="34" charset="-122"/>
-                <a:cs typeface="Calibri" pitchFamily="34" charset="-120"/>
-              </a:rPr>
-              <a:t>Check the correlation rule passes KOI fields through</a:t>
-            </a:r>
-            <a:endParaRPr lang="en-US" sz="1000" dirty="0"/>
-          </a:p>
-        </p:txBody>
-      </p:sp>
-      <p:sp>
-        <p:nvSpPr>
-          <p:cNvPr id="20" name="Shape 18"/>
-          <p:cNvSpPr/>
-          <p:nvPr/>
-        </p:nvSpPr>
-        <p:spPr>
-          <a:xfrm>
-            <a:off x="548640" y="3602736"/>
-            <a:ext cx="11064240" cy="457200"/>
-          </a:xfrm>
-          <a:prstGeom prst="roundRect">
-            <a:avLst>
-              <a:gd name="adj" fmla="val 10000"/>
-            </a:avLst>
-          </a:prstGeom>
-          <a:solidFill>
-            <a:srgbClr val="15171B"/>
-          </a:solidFill>
-          <a:ln w="12700">
-            <a:solidFill>
-              <a:srgbClr val="15171B"/>
-            </a:solidFill>
-            <a:prstDash val="solid"/>
-          </a:ln>
-        </p:spPr>
-      </p:sp>
-      <p:sp>
-        <p:nvSpPr>
-          <p:cNvPr id="21" name="Text 19"/>
-          <p:cNvSpPr/>
-          <p:nvPr/>
-        </p:nvSpPr>
-        <p:spPr>
-          <a:xfrm>
-            <a:off x="822960" y="3730752"/>
-            <a:ext cx="3017520" cy="237744"/>
-          </a:xfrm>
-          <a:prstGeom prst="rect">
-            <a:avLst/>
-          </a:prstGeom>
-          <a:noFill/>
-          <a:ln/>
-        </p:spPr>
-        <p:txBody>
-          <a:bodyPr wrap="square" lIns="0" tIns="0" rIns="0" bIns="0" rtlCol="0" anchor="t"/>
-          <a:lstStyle/>
-          <a:p>
-            <a:pPr indent="0" marL="0">
-              <a:buNone/>
-            </a:pPr>
-            <a:r>
-              <a:rPr lang="en-US" sz="1100" b="1" dirty="0">
-                <a:solidFill>
-                  <a:srgbClr val="FFFFFF"/>
-                </a:solidFill>
-                <a:latin typeface="Calibri" pitchFamily="34" charset="0"/>
-                <a:ea typeface="Calibri" pitchFamily="34" charset="-122"/>
-                <a:cs typeface="Calibri" pitchFamily="34" charset="-120"/>
-              </a:rPr>
-              <a:t>Alert fields empty</a:t>
-            </a:r>
-            <a:endParaRPr lang="en-US" sz="1100" dirty="0"/>
-          </a:p>
-        </p:txBody>
-      </p:sp>
-      <p:sp>
-        <p:nvSpPr>
-          <p:cNvPr id="22" name="Text 20"/>
-          <p:cNvSpPr/>
-          <p:nvPr/>
-        </p:nvSpPr>
-        <p:spPr>
-          <a:xfrm>
-            <a:off x="4023360" y="3739896"/>
-            <a:ext cx="3108960" cy="237744"/>
-          </a:xfrm>
-          <a:prstGeom prst="rect">
-            <a:avLst/>
-          </a:prstGeom>
-          <a:noFill/>
-          <a:ln/>
-        </p:spPr>
-        <p:txBody>
-          <a:bodyPr wrap="square" lIns="0" tIns="0" rIns="0" bIns="0" rtlCol="0" anchor="t"/>
-          <a:lstStyle/>
-          <a:p>
-            <a:pPr indent="0" marL="0">
-              <a:buNone/>
-            </a:pPr>
-            <a:r>
-              <a:rPr lang="en-US" sz="1000" dirty="0">
-                <a:solidFill>
-                  <a:srgbClr val="F5A524"/>
-                </a:solidFill>
-                <a:latin typeface="Calibri" pitchFamily="34" charset="0"/>
-                <a:ea typeface="Calibri" pitchFamily="34" charset="-122"/>
-                <a:cs typeface="Calibri" pitchFamily="34" charset="-120"/>
-              </a:rPr>
-              <a:t>Triage has not run on that alert</a:t>
-            </a:r>
-            <a:endParaRPr lang="en-US" sz="1000" dirty="0"/>
-          </a:p>
-        </p:txBody>
-      </p:sp>
-      <p:sp>
-        <p:nvSpPr>
-          <p:cNvPr id="23" name="Text 21"/>
-          <p:cNvSpPr/>
-          <p:nvPr/>
-        </p:nvSpPr>
-        <p:spPr>
-          <a:xfrm>
-            <a:off x="7315200" y="3739896"/>
-            <a:ext cx="4023360" cy="237744"/>
-          </a:xfrm>
-          <a:prstGeom prst="rect">
-            <a:avLst/>
-          </a:prstGeom>
-          <a:noFill/>
-          <a:ln/>
-        </p:spPr>
-        <p:txBody>
-          <a:bodyPr wrap="square" lIns="0" tIns="0" rIns="0" bIns="0" rtlCol="0" anchor="t"/>
-          <a:lstStyle/>
-          <a:p>
-            <a:pPr indent="0" marL="0">
-              <a:buNone/>
-            </a:pPr>
-            <a:r>
-              <a:rPr lang="en-US" sz="1000" dirty="0">
-                <a:solidFill>
-                  <a:srgbClr val="B4B7BD"/>
-                </a:solidFill>
-                <a:latin typeface="Calibri" pitchFamily="34" charset="0"/>
-                <a:ea typeface="Calibri" pitchFamily="34" charset="-122"/>
-                <a:cs typeface="Calibri" pitchFamily="34" charset="-120"/>
-              </a:rPr>
-              <a:t>Triage writes them — run it first</a:t>
-            </a:r>
-            <a:endParaRPr lang="en-US" sz="1000" dirty="0"/>
-          </a:p>
-        </p:txBody>
-      </p:sp>
-      <p:sp>
-        <p:nvSpPr>
-          <p:cNvPr id="24" name="Shape 22"/>
-          <p:cNvSpPr/>
-          <p:nvPr/>
-        </p:nvSpPr>
-        <p:spPr>
-          <a:xfrm>
-            <a:off x="548640" y="4160520"/>
-            <a:ext cx="11064240" cy="457200"/>
-          </a:xfrm>
-          <a:prstGeom prst="roundRect">
-            <a:avLst>
-              <a:gd name="adj" fmla="val 10000"/>
-            </a:avLst>
-          </a:prstGeom>
-          <a:solidFill>
-            <a:srgbClr val="15171B"/>
-          </a:solidFill>
-          <a:ln w="12700">
-            <a:solidFill>
-              <a:srgbClr val="15171B"/>
-            </a:solidFill>
-            <a:prstDash val="solid"/>
-          </a:ln>
-        </p:spPr>
-      </p:sp>
-      <p:sp>
-        <p:nvSpPr>
-          <p:cNvPr id="25" name="Text 23"/>
-          <p:cNvSpPr/>
-          <p:nvPr/>
-        </p:nvSpPr>
-        <p:spPr>
-          <a:xfrm>
-            <a:off x="822960" y="4288536"/>
-            <a:ext cx="3017520" cy="237744"/>
-          </a:xfrm>
-          <a:prstGeom prst="rect">
-            <a:avLst/>
-          </a:prstGeom>
-          <a:noFill/>
-          <a:ln/>
-        </p:spPr>
-        <p:txBody>
-          <a:bodyPr wrap="square" lIns="0" tIns="0" rIns="0" bIns="0" rtlCol="0" anchor="t"/>
-          <a:lstStyle/>
-          <a:p>
-            <a:pPr indent="0" marL="0">
-              <a:buNone/>
-            </a:pPr>
-            <a:r>
-              <a:rPr lang="en-US" sz="1100" b="1" dirty="0">
-                <a:solidFill>
-                  <a:srgbClr val="FFFFFF"/>
-                </a:solidFill>
-                <a:latin typeface="Calibri" pitchFamily="34" charset="0"/>
-                <a:ea typeface="Calibri" pitchFamily="34" charset="-122"/>
-                <a:cs typeface="Calibri" pitchFamily="34" charset="-120"/>
-              </a:rPr>
-              <a:t>Hunt sweep skips immediately</a:t>
-            </a:r>
-            <a:endParaRPr lang="en-US" sz="1100" dirty="0"/>
-          </a:p>
-        </p:txBody>
-      </p:sp>
-      <p:sp>
-        <p:nvSpPr>
-          <p:cNvPr id="26" name="Text 24"/>
-          <p:cNvSpPr/>
-          <p:nvPr/>
-        </p:nvSpPr>
-        <p:spPr>
-          <a:xfrm>
-            <a:off x="4023360" y="4297680"/>
-            <a:ext cx="3108960" cy="237744"/>
-          </a:xfrm>
-          <a:prstGeom prst="rect">
-            <a:avLst/>
-          </a:prstGeom>
-          <a:noFill/>
-          <a:ln/>
-        </p:spPr>
-        <p:txBody>
-          <a:bodyPr wrap="square" lIns="0" tIns="0" rIns="0" bIns="0" rtlCol="0" anchor="t"/>
-          <a:lstStyle/>
-          <a:p>
-            <a:pPr indent="0" marL="0">
-              <a:buNone/>
-            </a:pPr>
-            <a:r>
-              <a:rPr lang="en-US" sz="1000" dirty="0">
-                <a:solidFill>
-                  <a:srgbClr val="F5A524"/>
-                </a:solidFill>
-                <a:latin typeface="Calibri" pitchFamily="34" charset="0"/>
-                <a:ea typeface="Calibri" pitchFamily="34" charset="-122"/>
-                <a:cs typeface="Calibri" pitchFamily="34" charset="-120"/>
-              </a:rPr>
-              <a:t>The XQL engine did not answer</a:t>
-            </a:r>
-            <a:endParaRPr lang="en-US" sz="1000" dirty="0"/>
-          </a:p>
-        </p:txBody>
-      </p:sp>
-      <p:sp>
-        <p:nvSpPr>
-          <p:cNvPr id="27" name="Text 25"/>
-          <p:cNvSpPr/>
-          <p:nvPr/>
-        </p:nvSpPr>
-        <p:spPr>
-          <a:xfrm>
-            <a:off x="7315200" y="4297680"/>
-            <a:ext cx="4023360" cy="237744"/>
-          </a:xfrm>
-          <a:prstGeom prst="rect">
-            <a:avLst/>
-          </a:prstGeom>
-          <a:noFill/>
-          <a:ln/>
-        </p:spPr>
-        <p:txBody>
-          <a:bodyPr wrap="square" lIns="0" tIns="0" rIns="0" bIns="0" rtlCol="0" anchor="t"/>
-          <a:lstStyle/>
-          <a:p>
-            <a:pPr indent="0" marL="0">
-              <a:buNone/>
-            </a:pPr>
-            <a:r>
-              <a:rPr lang="en-US" sz="1000" dirty="0">
-                <a:solidFill>
-                  <a:srgbClr val="B4B7BD"/>
-                </a:solidFill>
-                <a:latin typeface="Calibri" pitchFamily="34" charset="0"/>
-                <a:ea typeface="Calibri" pitchFamily="34" charset="-122"/>
-                <a:cs typeface="Calibri" pitchFamily="34" charset="-120"/>
-              </a:rPr>
-              <a:t>Re-run. XSIAM provisions the engine, so this should not persist</a:t>
-            </a:r>
-            <a:endParaRPr lang="en-US" sz="1000" dirty="0"/>
-          </a:p>
-        </p:txBody>
-      </p:sp>
-      <p:sp>
-        <p:nvSpPr>
-          <p:cNvPr id="28" name="Shape 26"/>
-          <p:cNvSpPr/>
-          <p:nvPr/>
-        </p:nvSpPr>
-        <p:spPr>
-          <a:xfrm>
-            <a:off x="548640" y="4718304"/>
-            <a:ext cx="11064240" cy="457200"/>
-          </a:xfrm>
-          <a:prstGeom prst="roundRect">
-            <a:avLst>
-              <a:gd name="adj" fmla="val 10000"/>
-            </a:avLst>
-          </a:prstGeom>
-          <a:solidFill>
-            <a:srgbClr val="15171B"/>
-          </a:solidFill>
-          <a:ln w="12700">
-            <a:solidFill>
-              <a:srgbClr val="15171B"/>
-            </a:solidFill>
-            <a:prstDash val="solid"/>
-          </a:ln>
-        </p:spPr>
-      </p:sp>
-      <p:sp>
-        <p:nvSpPr>
-          <p:cNvPr id="29" name="Text 27"/>
-          <p:cNvSpPr/>
-          <p:nvPr/>
-        </p:nvSpPr>
-        <p:spPr>
-          <a:xfrm>
-            <a:off x="822960" y="4846320"/>
-            <a:ext cx="3017520" cy="237744"/>
-          </a:xfrm>
-          <a:prstGeom prst="rect">
-            <a:avLst/>
-          </a:prstGeom>
-          <a:noFill/>
-          <a:ln/>
-        </p:spPr>
-        <p:txBody>
-          <a:bodyPr wrap="square" lIns="0" tIns="0" rIns="0" bIns="0" rtlCol="0" anchor="t"/>
-          <a:lstStyle/>
-          <a:p>
-            <a:pPr indent="0" marL="0">
-              <a:buNone/>
-            </a:pPr>
-            <a:r>
-              <a:rPr lang="en-US" sz="1100" b="1" dirty="0">
-                <a:solidFill>
-                  <a:srgbClr val="FFFFFF"/>
-                </a:solidFill>
-                <a:latin typeface="Calibri" pitchFamily="34" charset="0"/>
-                <a:ea typeface="Calibri" pitchFamily="34" charset="-122"/>
-                <a:cs typeface="Calibri" pitchFamily="34" charset="-120"/>
-              </a:rPr>
-              <a:t>Tracker List stays empty</a:t>
-            </a:r>
-            <a:endParaRPr lang="en-US" sz="1100" dirty="0"/>
-          </a:p>
-        </p:txBody>
-      </p:sp>
-      <p:sp>
-        <p:nvSpPr>
-          <p:cNvPr id="30" name="Text 28"/>
-          <p:cNvSpPr/>
-          <p:nvPr/>
-        </p:nvSpPr>
-        <p:spPr>
-          <a:xfrm>
-            <a:off x="4023360" y="4855464"/>
-            <a:ext cx="3108960" cy="237744"/>
-          </a:xfrm>
-          <a:prstGeom prst="rect">
-            <a:avLst/>
-          </a:prstGeom>
-          <a:noFill/>
-          <a:ln/>
-        </p:spPr>
-        <p:txBody>
-          <a:bodyPr wrap="square" lIns="0" tIns="0" rIns="0" bIns="0" rtlCol="0" anchor="t"/>
-          <a:lstStyle/>
-          <a:p>
-            <a:pPr indent="0" marL="0">
-              <a:buNone/>
-            </a:pPr>
-            <a:r>
-              <a:rPr lang="en-US" sz="1000" dirty="0">
-                <a:solidFill>
-                  <a:srgbClr val="F5A524"/>
-                </a:solidFill>
-                <a:latin typeface="Calibri" pitchFamily="34" charset="0"/>
-                <a:ea typeface="Calibri" pitchFamily="34" charset="-122"/>
-                <a:cs typeface="Calibri" pitchFamily="34" charset="-120"/>
-              </a:rPr>
-              <a:t>No Core REST API instance</a:t>
-            </a:r>
-            <a:endParaRPr lang="en-US" sz="1000" dirty="0"/>
-          </a:p>
-        </p:txBody>
-      </p:sp>
-      <p:sp>
-        <p:nvSpPr>
-          <p:cNvPr id="31" name="Text 29"/>
-          <p:cNvSpPr/>
-          <p:nvPr/>
-        </p:nvSpPr>
-        <p:spPr>
-          <a:xfrm>
-            <a:off x="7315200" y="4855464"/>
-            <a:ext cx="4023360" cy="237744"/>
-          </a:xfrm>
-          <a:prstGeom prst="rect">
-            <a:avLst/>
-          </a:prstGeom>
-          <a:noFill/>
-          <a:ln/>
-        </p:spPr>
-        <p:txBody>
-          <a:bodyPr wrap="square" lIns="0" tIns="0" rIns="0" bIns="0" rtlCol="0" anchor="t"/>
-          <a:lstStyle/>
-          <a:p>
-            <a:pPr indent="0" marL="0">
-              <a:buNone/>
-            </a:pPr>
-            <a:r>
-              <a:rPr lang="en-US" sz="1000" dirty="0">
-                <a:solidFill>
-                  <a:srgbClr val="B4B7BD"/>
-                </a:solidFill>
-                <a:latin typeface="Calibri" pitchFamily="34" charset="0"/>
-                <a:ea typeface="Calibri" pitchFamily="34" charset="-122"/>
-                <a:cs typeface="Calibri" pitchFamily="34" charset="-120"/>
-              </a:rPr>
-              <a:t>Configure it — Test 8 cannot pass without it</a:t>
-            </a:r>
-            <a:endParaRPr lang="en-US" sz="1000" dirty="0"/>
-          </a:p>
-        </p:txBody>
-      </p:sp>
-      <p:sp>
-        <p:nvSpPr>
-          <p:cNvPr id="32" name="Shape 30"/>
-          <p:cNvSpPr/>
-          <p:nvPr/>
-        </p:nvSpPr>
-        <p:spPr>
-          <a:xfrm>
-            <a:off x="548640" y="5276088"/>
-            <a:ext cx="11064240" cy="457200"/>
-          </a:xfrm>
-          <a:prstGeom prst="roundRect">
-            <a:avLst>
-              <a:gd name="adj" fmla="val 10000"/>
-            </a:avLst>
-          </a:prstGeom>
-          <a:solidFill>
-            <a:srgbClr val="15171B"/>
-          </a:solidFill>
-          <a:ln w="12700">
-            <a:solidFill>
-              <a:srgbClr val="15171B"/>
-            </a:solidFill>
-            <a:prstDash val="solid"/>
-          </a:ln>
-        </p:spPr>
-      </p:sp>
-      <p:sp>
-        <p:nvSpPr>
-          <p:cNvPr id="33" name="Text 31"/>
-          <p:cNvSpPr/>
-          <p:nvPr/>
-        </p:nvSpPr>
-        <p:spPr>
-          <a:xfrm>
-            <a:off x="822960" y="5404104"/>
-            <a:ext cx="3017520" cy="237744"/>
-          </a:xfrm>
-          <a:prstGeom prst="rect">
-            <a:avLst/>
-          </a:prstGeom>
-          <a:noFill/>
-          <a:ln/>
-        </p:spPr>
-        <p:txBody>
-          <a:bodyPr wrap="square" lIns="0" tIns="0" rIns="0" bIns="0" rtlCol="0" anchor="t"/>
-          <a:lstStyle/>
-          <a:p>
-            <a:pPr indent="0" marL="0">
-              <a:buNone/>
-            </a:pPr>
-            <a:r>
-              <a:rPr lang="en-US" sz="1100" b="1" dirty="0">
-                <a:solidFill>
-                  <a:srgbClr val="FFFFFF"/>
-                </a:solidFill>
-                <a:latin typeface="Calibri" pitchFamily="34" charset="0"/>
-                <a:ea typeface="Calibri" pitchFamily="34" charset="-122"/>
-                <a:cs typeface="Calibri" pitchFamily="34" charset="-120"/>
-              </a:rPr>
-              <a:t>A Job never fires</a:t>
-            </a:r>
-            <a:endParaRPr lang="en-US" sz="1100" dirty="0"/>
-          </a:p>
-        </p:txBody>
-      </p:sp>
-      <p:sp>
-        <p:nvSpPr>
-          <p:cNvPr id="34" name="Text 32"/>
-          <p:cNvSpPr/>
-          <p:nvPr/>
-        </p:nvSpPr>
-        <p:spPr>
-          <a:xfrm>
-            <a:off x="4023360" y="5413248"/>
-            <a:ext cx="3108960" cy="237744"/>
-          </a:xfrm>
-          <a:prstGeom prst="rect">
-            <a:avLst/>
-          </a:prstGeom>
-          <a:noFill/>
-          <a:ln/>
-        </p:spPr>
-        <p:txBody>
-          <a:bodyPr wrap="square" lIns="0" tIns="0" rIns="0" bIns="0" rtlCol="0" anchor="t"/>
-          <a:lstStyle/>
-          <a:p>
-            <a:pPr indent="0" marL="0">
-              <a:buNone/>
-            </a:pPr>
-            <a:r>
-              <a:rPr lang="en-US" sz="1000" dirty="0">
-                <a:solidFill>
-                  <a:srgbClr val="F5A524"/>
-                </a:solidFill>
-                <a:latin typeface="Calibri" pitchFamily="34" charset="0"/>
-                <a:ea typeface="Calibri" pitchFamily="34" charset="-122"/>
-                <a:cs typeface="Calibri" pitchFamily="34" charset="-120"/>
-              </a:rPr>
-              <a:t>It was created disabled</a:t>
-            </a:r>
-            <a:endParaRPr lang="en-US" sz="1000" dirty="0"/>
-          </a:p>
-        </p:txBody>
-      </p:sp>
-      <p:sp>
-        <p:nvSpPr>
-          <p:cNvPr id="35" name="Text 33"/>
-          <p:cNvSpPr/>
-          <p:nvPr/>
-        </p:nvSpPr>
-        <p:spPr>
-          <a:xfrm>
-            <a:off x="7315200" y="5413248"/>
-            <a:ext cx="4023360" cy="237744"/>
-          </a:xfrm>
-          <a:prstGeom prst="rect">
-            <a:avLst/>
-          </a:prstGeom>
-          <a:noFill/>
-          <a:ln/>
-        </p:spPr>
-        <p:txBody>
-          <a:bodyPr wrap="square" lIns="0" tIns="0" rIns="0" bIns="0" rtlCol="0" anchor="t"/>
-          <a:lstStyle/>
-          <a:p>
-            <a:pPr indent="0" marL="0">
-              <a:buNone/>
-            </a:pPr>
-            <a:r>
-              <a:rPr lang="en-US" sz="1000" dirty="0">
-                <a:solidFill>
-                  <a:srgbClr val="B4B7BD"/>
-                </a:solidFill>
-                <a:latin typeface="Calibri" pitchFamily="34" charset="0"/>
-                <a:ea typeface="Calibri" pitchFamily="34" charset="-122"/>
-                <a:cs typeface="Calibri" pitchFamily="34" charset="-120"/>
-              </a:rPr>
-              <a:t>Enable it and confirm a next-run time is shown</a:t>
-            </a:r>
-            <a:endParaRPr lang="en-US" sz="1000" dirty="0"/>
-          </a:p>
-        </p:txBody>
-      </p:sp>
-      <p:sp>
-        <p:nvSpPr>
-          <p:cNvPr id="36" name="Text 34"/>
-          <p:cNvSpPr/>
-          <p:nvPr/>
-        </p:nvSpPr>
-        <p:spPr>
-          <a:xfrm>
-            <a:off x="548640" y="5925312"/>
-            <a:ext cx="11064240" cy="274320"/>
-          </a:xfrm>
-          <a:prstGeom prst="rect">
-            <a:avLst/>
-          </a:prstGeom>
-          <a:noFill/>
-          <a:ln/>
-        </p:spPr>
-        <p:txBody>
-          <a:bodyPr wrap="square" lIns="0" tIns="0" rIns="0" bIns="0" rtlCol="0" anchor="t"/>
-          <a:lstStyle/>
-          <a:p>
-            <a:pPr indent="0" marL="0">
-              <a:buNone/>
-            </a:pPr>
-            <a:r>
-              <a:rPr lang="en-US" sz="1050" i="1" dirty="0">
-                <a:solidFill>
-                  <a:srgbClr val="6E747E"/>
-                </a:solidFill>
-                <a:latin typeface="Calibri" pitchFamily="34" charset="0"/>
-                <a:ea typeface="Calibri" pitchFamily="34" charset="-122"/>
-                <a:cs typeface="Calibri" pitchFamily="34" charset="-120"/>
-              </a:rPr>
-              <a:t>Seven of these eight are tenant setup, not the pack. Check the amber panel on the test before raising a defect.</a:t>
-            </a:r>
-            <a:endParaRPr lang="en-US" sz="1050" dirty="0"/>
-          </a:p>
-        </p:txBody>
-      </p:sp>
-    </p:spTree>
-  </p:cSld>
-  <p:clrMapOvr>
-    <a:masterClrMapping/>
-  </p:clrMapOvr>
-</p:sld>
-</file>
-
-<file path=ppt/slides/slide16.xml><?xml version="1.0" encoding="utf-8"?>
-<p:sld xmlns:a="http://schemas.openxmlformats.org/drawingml/2006/main" xmlns:r="http://schemas.openxmlformats.org/officeDocument/2006/relationships" xmlns:p="http://schemas.openxmlformats.org/presentationml/2006/main">
-  <p:cSld name="Slide 16">
-    <p:bg>
-      <p:bgPr>
-        <a:solidFill>
-          <a:srgbClr val="000000"/>
-        </a:solidFill>
-      </p:bgPr>
-    </p:bg>
-    <p:spTree>
-      <p:nvGrpSpPr>
-        <p:cNvPr id="1" name=""/>
-        <p:cNvGrpSpPr/>
-        <p:nvPr/>
-      </p:nvGrpSpPr>
-      <p:grpSpPr>
-        <a:xfrm>
-          <a:off x="0" y="0"/>
-          <a:ext cx="0" cy="0"/>
-          <a:chOff x="0" y="0"/>
-          <a:chExt cx="0" cy="0"/>
-        </a:xfrm>
-      </p:grpSpPr>
-      <p:sp>
-        <p:nvSpPr>
           <p:cNvPr id="2" name="Shape 0"/>
           <p:cNvSpPr/>
           <p:nvPr/>
@@ -14438,13 +12454,13 @@
             <a:r>
               <a:rPr lang="en-US" sz="1100" b="1" spc="150" kern="0" dirty="0">
                 <a:solidFill>
-                  <a:srgbClr val="F5A524"/>
-                </a:solidFill>
-                <a:latin typeface="Calibri" pitchFamily="34" charset="0"/>
-                <a:ea typeface="Calibri" pitchFamily="34" charset="-122"/>
-                <a:cs typeface="Calibri" pitchFamily="34" charset="-120"/>
-              </a:rPr>
-              <a:t>WHAT YOU NEED FIRST</a:t>
+                  <a:srgbClr val="22D3EE"/>
+                </a:solidFill>
+                <a:latin typeface="Calibri" pitchFamily="34" charset="0"/>
+                <a:ea typeface="Calibri" pitchFamily="34" charset="-122"/>
+                <a:cs typeface="Calibri" pitchFamily="34" charset="-120"/>
+              </a:rPr>
+              <a:t>PACK CONTENT</a:t>
             </a:r>
             <a:endParaRPr lang="en-US" sz="1100" dirty="0"/>
           </a:p>
@@ -14486,7 +12502,7 @@
                 <a:ea typeface="Calibri" pitchFamily="34" charset="-122"/>
                 <a:cs typeface="Calibri" pitchFamily="34" charset="-120"/>
               </a:rPr>
-              <a:t>The tenant setup this test depends on. If something here is missing the test cannot pass, and it will look like a product fault when it is not.</a:t>
+              <a:t>The content items that must be on the tenant for this test — playbooks, automations, rules, Lists. Useful if you upload the pack piece by piece rather than in one go.</a:t>
             </a:r>
             <a:endParaRPr lang="en-US" sz="1100" dirty="0"/>
           </a:p>
@@ -14546,13 +12562,13 @@
             <a:r>
               <a:rPr lang="en-US" sz="1100" b="1" spc="150" kern="0" dirty="0">
                 <a:solidFill>
-                  <a:srgbClr val="E8551F"/>
-                </a:solidFill>
-                <a:latin typeface="Calibri" pitchFamily="34" charset="0"/>
-                <a:ea typeface="Calibri" pitchFamily="34" charset="-122"/>
-                <a:cs typeface="Calibri" pitchFamily="34" charset="-120"/>
-              </a:rPr>
-              <a:t>STEPS</a:t>
+                  <a:srgbClr val="F5A524"/>
+                </a:solidFill>
+                <a:latin typeface="Calibri" pitchFamily="34" charset="0"/>
+                <a:ea typeface="Calibri" pitchFamily="34" charset="-122"/>
+                <a:cs typeface="Calibri" pitchFamily="34" charset="-120"/>
+              </a:rPr>
+              <a:t>TENANT SETUP</a:t>
             </a:r>
             <a:endParaRPr lang="en-US" sz="1100" dirty="0"/>
           </a:p>
@@ -14594,7 +12610,7 @@
                 <a:ea typeface="Calibri" pitchFamily="34" charset="-122"/>
                 <a:cs typeface="Calibri" pitchFamily="34" charset="-120"/>
               </a:rPr>
-              <a:t>What to click, in order, in the Cortex XSIAM console. Anything to paste is shown in monospace.</a:t>
+              <a:t>What you configure yourself: integration instances, an endpoint group, a script in Action Center, the configuration List.</a:t>
             </a:r>
             <a:endParaRPr lang="en-US" sz="1100" dirty="0"/>
           </a:p>
@@ -14654,13 +12670,13 @@
             <a:r>
               <a:rPr lang="en-US" sz="1100" b="1" spc="150" kern="0" dirty="0">
                 <a:solidFill>
-                  <a:srgbClr val="3FB950"/>
-                </a:solidFill>
-                <a:latin typeface="Calibri" pitchFamily="34" charset="0"/>
-                <a:ea typeface="Calibri" pitchFamily="34" charset="-122"/>
-                <a:cs typeface="Calibri" pitchFamily="34" charset="-120"/>
-              </a:rPr>
-              <a:t>WHAT TO EXPECT</a:t>
+                  <a:srgbClr val="E8551F"/>
+                </a:solidFill>
+                <a:latin typeface="Calibri" pitchFamily="34" charset="0"/>
+                <a:ea typeface="Calibri" pitchFamily="34" charset="-122"/>
+                <a:cs typeface="Calibri" pitchFamily="34" charset="-120"/>
+              </a:rPr>
+              <a:t>STEPS  +  WHAT TO EXPECT</a:t>
             </a:r>
             <a:endParaRPr lang="en-US" sz="1100" dirty="0"/>
           </a:p>
@@ -14702,7 +12718,7 @@
                 <a:ea typeface="Calibri" pitchFamily="34" charset="-122"/>
                 <a:cs typeface="Calibri" pitchFamily="34" charset="-120"/>
               </a:rPr>
-              <a:t>What a passing test looks like. Where a result commonly looks wrong but is correct, it says so.</a:t>
+              <a:t>What to click, in order, in the Cortex XSIAM console — and what a passing test looks like. Anything to paste is shown in monospace.</a:t>
             </a:r>
             <a:endParaRPr lang="en-US" sz="1100" dirty="0"/>
           </a:p>
@@ -14843,13 +12859,13 @@
             <a:r>
               <a:rPr lang="en-US" sz="1100" i="1" dirty="0">
                 <a:solidFill>
-                  <a:srgbClr val="F5A524"/>
-                </a:solidFill>
-                <a:latin typeface="Calibri" pitchFamily="34" charset="0"/>
-                <a:ea typeface="Calibri" pitchFamily="34" charset="-122"/>
-                <a:cs typeface="Calibri" pitchFamily="34" charset="-120"/>
-              </a:rPr>
-              <a:t>A test that fails on a missing prerequisite is not a product defect — check the amber panel first.</a:t>
+                  <a:srgbClr val="6E747E"/>
+                </a:solidFill>
+                <a:latin typeface="Calibri" pitchFamily="34" charset="0"/>
+                <a:ea typeface="Calibri" pitchFamily="34" charset="-122"/>
+                <a:cs typeface="Calibri" pitchFamily="34" charset="-120"/>
+              </a:rPr>
+              <a:t>Each test lists its own prerequisites — set those up first and the test runs straight through.</a:t>
             </a:r>
             <a:endParaRPr lang="en-US" sz="1100" dirty="0"/>
           </a:p>
@@ -16363,7 +14379,7 @@
                 <a:ea typeface="Calibri" pitchFamily="34" charset="-122"/>
                 <a:cs typeface="Calibri" pitchFamily="34" charset="-120"/>
               </a:rPr>
-              <a:t>Two are easy to miss. The Marketplace KOI pack must be installed first — this extension ships no integration. And the Core REST API instance: without it the Script Runner's tracker stays empty and every scan run does nothing, which looks exactly like a broken playbook.</a:t>
+              <a:t>Two to set up before anything else. The Marketplace KOI pack must be installed first — this extension ships content only, no integration. The Core REST API instance is needed for tests 8 and 9, where the Script Runner reads endpoint groups through it.</a:t>
             </a:r>
             <a:endParaRPr lang="en-US" sz="1050" dirty="0"/>
           </a:p>
@@ -17526,141 +15542,6 @@
           </a:p>
         </p:txBody>
       </p:sp>
-      <p:sp>
-        <p:nvSpPr>
-          <p:cNvPr id="31" name="Shape 29"/>
-          <p:cNvSpPr/>
-          <p:nvPr/>
-        </p:nvSpPr>
-        <p:spPr>
-          <a:xfrm>
-            <a:off x="548640" y="4782312"/>
-            <a:ext cx="11064240" cy="658368"/>
-          </a:xfrm>
-          <a:prstGeom prst="roundRect">
-            <a:avLst>
-              <a:gd name="adj" fmla="val 6944"/>
-            </a:avLst>
-          </a:prstGeom>
-          <a:solidFill>
-            <a:srgbClr val="1C2026"/>
-          </a:solidFill>
-          <a:ln w="12700">
-            <a:solidFill>
-              <a:srgbClr val="1C2026"/>
-            </a:solidFill>
-            <a:prstDash val="solid"/>
-          </a:ln>
-        </p:spPr>
-      </p:sp>
-      <p:sp>
-        <p:nvSpPr>
-          <p:cNvPr id="32" name="Shape 30"/>
-          <p:cNvSpPr/>
-          <p:nvPr/>
-        </p:nvSpPr>
-        <p:spPr>
-          <a:xfrm>
-            <a:off x="786384" y="4965192"/>
-            <a:ext cx="292608" cy="292608"/>
-          </a:xfrm>
-          <a:prstGeom prst="roundRect">
-            <a:avLst>
-              <a:gd name="adj" fmla="val 28125"/>
-            </a:avLst>
-          </a:prstGeom>
-          <a:solidFill>
-            <a:srgbClr val="F5A524"/>
-          </a:solidFill>
-          <a:ln w="12700">
-            <a:solidFill>
-              <a:srgbClr val="F5A524"/>
-            </a:solidFill>
-            <a:prstDash val="solid"/>
-          </a:ln>
-        </p:spPr>
-      </p:sp>
-      <p:sp>
-        <p:nvSpPr>
-          <p:cNvPr id="33" name="Text 31"/>
-          <p:cNvSpPr/>
-          <p:nvPr/>
-        </p:nvSpPr>
-        <p:spPr>
-          <a:xfrm>
-            <a:off x="786384" y="4965192"/>
-            <a:ext cx="292608" cy="292608"/>
-          </a:xfrm>
-          <a:prstGeom prst="rect">
-            <a:avLst/>
-          </a:prstGeom>
-          <a:noFill/>
-          <a:ln/>
-        </p:spPr>
-        <p:txBody>
-          <a:bodyPr wrap="square" lIns="0" tIns="0" rIns="0" bIns="0" rtlCol="0" anchor="ctr"/>
-          <a:lstStyle/>
-          <a:p>
-            <a:pPr algn="ctr" indent="0" marL="0">
-              <a:buNone/>
-            </a:pPr>
-            <a:r>
-              <a:rPr lang="en-US" sz="1300" b="1" dirty="0">
-                <a:solidFill>
-                  <a:srgbClr val="FFFFFF"/>
-                </a:solidFill>
-                <a:latin typeface="Calibri" pitchFamily="34" charset="0"/>
-                <a:ea typeface="Calibri" pitchFamily="34" charset="-122"/>
-                <a:cs typeface="Calibri" pitchFamily="34" charset="-120"/>
-              </a:rPr>
-              <a:t>!</a:t>
-            </a:r>
-            <a:endParaRPr lang="en-US" sz="1300" dirty="0"/>
-          </a:p>
-        </p:txBody>
-      </p:sp>
-      <p:sp>
-        <p:nvSpPr>
-          <p:cNvPr id="34" name="Text 32"/>
-          <p:cNvSpPr/>
-          <p:nvPr/>
-        </p:nvSpPr>
-        <p:spPr>
-          <a:xfrm>
-            <a:off x="1243584" y="4892040"/>
-            <a:ext cx="10058400" cy="438912"/>
-          </a:xfrm>
-          <a:prstGeom prst="rect">
-            <a:avLst/>
-          </a:prstGeom>
-          <a:noFill/>
-          <a:ln/>
-        </p:spPr>
-        <p:txBody>
-          <a:bodyPr wrap="square" lIns="0" tIns="0" rIns="0" bIns="0" rtlCol="0" anchor="t"/>
-          <a:lstStyle/>
-          <a:p>
-            <a:pPr indent="0" marL="0">
-              <a:lnSpc>
-                <a:spcPts val="1200"/>
-              </a:lnSpc>
-              <a:buNone/>
-            </a:pPr>
-            <a:r>
-              <a:rPr lang="en-US" sz="1000" dirty="0">
-                <a:solidFill>
-                  <a:srgbClr val="B4B7BD"/>
-                </a:solidFill>
-                <a:latin typeface="Calibri" pitchFamily="34" charset="0"/>
-                <a:ea typeface="Calibri" pitchFamily="34" charset="-122"/>
-                <a:cs typeface="Calibri" pitchFamily="34" charset="-120"/>
-              </a:rPr>
-              <a:t>A 403 here almost always means egress rather than a bad key — KOI restricts its sensitive endpoints by source IP. Run the instance on a Cortex engine whose address KOI accepts. A 401 means the key itself.</a:t>
-            </a:r>
-            <a:endParaRPr lang="en-US" sz="1000" dirty="0"/>
-          </a:p>
-        </p:txBody>
-      </p:sp>
     </p:spTree>
   </p:cSld>
   <p:clrMapOvr>
@@ -18980,141 +16861,6 @@
           </a:p>
         </p:txBody>
       </p:sp>
-      <p:sp>
-        <p:nvSpPr>
-          <p:cNvPr id="35" name="Shape 33"/>
-          <p:cNvSpPr/>
-          <p:nvPr/>
-        </p:nvSpPr>
-        <p:spPr>
-          <a:xfrm>
-            <a:off x="548640" y="4782312"/>
-            <a:ext cx="11064240" cy="658368"/>
-          </a:xfrm>
-          <a:prstGeom prst="roundRect">
-            <a:avLst>
-              <a:gd name="adj" fmla="val 6944"/>
-            </a:avLst>
-          </a:prstGeom>
-          <a:solidFill>
-            <a:srgbClr val="1C2026"/>
-          </a:solidFill>
-          <a:ln w="12700">
-            <a:solidFill>
-              <a:srgbClr val="1C2026"/>
-            </a:solidFill>
-            <a:prstDash val="solid"/>
-          </a:ln>
-        </p:spPr>
-      </p:sp>
-      <p:sp>
-        <p:nvSpPr>
-          <p:cNvPr id="36" name="Shape 34"/>
-          <p:cNvSpPr/>
-          <p:nvPr/>
-        </p:nvSpPr>
-        <p:spPr>
-          <a:xfrm>
-            <a:off x="786384" y="4965192"/>
-            <a:ext cx="292608" cy="292608"/>
-          </a:xfrm>
-          <a:prstGeom prst="roundRect">
-            <a:avLst>
-              <a:gd name="adj" fmla="val 28125"/>
-            </a:avLst>
-          </a:prstGeom>
-          <a:solidFill>
-            <a:srgbClr val="F5A524"/>
-          </a:solidFill>
-          <a:ln w="12700">
-            <a:solidFill>
-              <a:srgbClr val="F5A524"/>
-            </a:solidFill>
-            <a:prstDash val="solid"/>
-          </a:ln>
-        </p:spPr>
-      </p:sp>
-      <p:sp>
-        <p:nvSpPr>
-          <p:cNvPr id="37" name="Text 35"/>
-          <p:cNvSpPr/>
-          <p:nvPr/>
-        </p:nvSpPr>
-        <p:spPr>
-          <a:xfrm>
-            <a:off x="786384" y="4965192"/>
-            <a:ext cx="292608" cy="292608"/>
-          </a:xfrm>
-          <a:prstGeom prst="rect">
-            <a:avLst/>
-          </a:prstGeom>
-          <a:noFill/>
-          <a:ln/>
-        </p:spPr>
-        <p:txBody>
-          <a:bodyPr wrap="square" lIns="0" tIns="0" rIns="0" bIns="0" rtlCol="0" anchor="ctr"/>
-          <a:lstStyle/>
-          <a:p>
-            <a:pPr algn="ctr" indent="0" marL="0">
-              <a:buNone/>
-            </a:pPr>
-            <a:r>
-              <a:rPr lang="en-US" sz="1300" b="1" dirty="0">
-                <a:solidFill>
-                  <a:srgbClr val="FFFFFF"/>
-                </a:solidFill>
-                <a:latin typeface="Calibri" pitchFamily="34" charset="0"/>
-                <a:ea typeface="Calibri" pitchFamily="34" charset="-122"/>
-                <a:cs typeface="Calibri" pitchFamily="34" charset="-120"/>
-              </a:rPr>
-              <a:t>!</a:t>
-            </a:r>
-            <a:endParaRPr lang="en-US" sz="1300" dirty="0"/>
-          </a:p>
-        </p:txBody>
-      </p:sp>
-      <p:sp>
-        <p:nvSpPr>
-          <p:cNvPr id="38" name="Text 36"/>
-          <p:cNvSpPr/>
-          <p:nvPr/>
-        </p:nvSpPr>
-        <p:spPr>
-          <a:xfrm>
-            <a:off x="1243584" y="4892040"/>
-            <a:ext cx="10058400" cy="438912"/>
-          </a:xfrm>
-          <a:prstGeom prst="rect">
-            <a:avLst/>
-          </a:prstGeom>
-          <a:noFill/>
-          <a:ln/>
-        </p:spPr>
-        <p:txBody>
-          <a:bodyPr wrap="square" lIns="0" tIns="0" rIns="0" bIns="0" rtlCol="0" anchor="t"/>
-          <a:lstStyle/>
-          <a:p>
-            <a:pPr indent="0" marL="0">
-              <a:lnSpc>
-                <a:spcPts val="1200"/>
-              </a:lnSpc>
-              <a:buNone/>
-            </a:pPr>
-            <a:r>
-              <a:rPr lang="en-US" sz="1000" dirty="0">
-                <a:solidFill>
-                  <a:srgbClr val="B4B7BD"/>
-                </a:solidFill>
-                <a:latin typeface="Calibri" pitchFamily="34" charset="0"/>
-                <a:ea typeface="Calibri" pitchFamily="34" charset="-122"/>
-                <a:cs typeface="Calibri" pitchFamily="34" charset="-120"/>
-              </a:rPr>
-              <a:t>The Marketplace KOI pack ships no parsing or modeling rules. If those promoted fields are missing, this extension is not installed or has not activated yet.</a:t>
-            </a:r>
-            <a:endParaRPr lang="en-US" sz="1000" dirty="0"/>
-          </a:p>
-        </p:txBody>
-      </p:sp>
     </p:spTree>
   </p:cSld>
   <p:clrMapOvr>
@@ -20353,141 +18099,6 @@
           </a:p>
         </p:txBody>
       </p:sp>
-      <p:sp>
-        <p:nvSpPr>
-          <p:cNvPr id="33" name="Shape 31"/>
-          <p:cNvSpPr/>
-          <p:nvPr/>
-        </p:nvSpPr>
-        <p:spPr>
-          <a:xfrm>
-            <a:off x="548640" y="4969764"/>
-            <a:ext cx="11064240" cy="658368"/>
-          </a:xfrm>
-          <a:prstGeom prst="roundRect">
-            <a:avLst>
-              <a:gd name="adj" fmla="val 6944"/>
-            </a:avLst>
-          </a:prstGeom>
-          <a:solidFill>
-            <a:srgbClr val="1C2026"/>
-          </a:solidFill>
-          <a:ln w="12700">
-            <a:solidFill>
-              <a:srgbClr val="1C2026"/>
-            </a:solidFill>
-            <a:prstDash val="solid"/>
-          </a:ln>
-        </p:spPr>
-      </p:sp>
-      <p:sp>
-        <p:nvSpPr>
-          <p:cNvPr id="34" name="Shape 32"/>
-          <p:cNvSpPr/>
-          <p:nvPr/>
-        </p:nvSpPr>
-        <p:spPr>
-          <a:xfrm>
-            <a:off x="786384" y="5152644"/>
-            <a:ext cx="292608" cy="292608"/>
-          </a:xfrm>
-          <a:prstGeom prst="roundRect">
-            <a:avLst>
-              <a:gd name="adj" fmla="val 28125"/>
-            </a:avLst>
-          </a:prstGeom>
-          <a:solidFill>
-            <a:srgbClr val="F5A524"/>
-          </a:solidFill>
-          <a:ln w="12700">
-            <a:solidFill>
-              <a:srgbClr val="F5A524"/>
-            </a:solidFill>
-            <a:prstDash val="solid"/>
-          </a:ln>
-        </p:spPr>
-      </p:sp>
-      <p:sp>
-        <p:nvSpPr>
-          <p:cNvPr id="35" name="Text 33"/>
-          <p:cNvSpPr/>
-          <p:nvPr/>
-        </p:nvSpPr>
-        <p:spPr>
-          <a:xfrm>
-            <a:off x="786384" y="5152644"/>
-            <a:ext cx="292608" cy="292608"/>
-          </a:xfrm>
-          <a:prstGeom prst="rect">
-            <a:avLst/>
-          </a:prstGeom>
-          <a:noFill/>
-          <a:ln/>
-        </p:spPr>
-        <p:txBody>
-          <a:bodyPr wrap="square" lIns="0" tIns="0" rIns="0" bIns="0" rtlCol="0" anchor="ctr"/>
-          <a:lstStyle/>
-          <a:p>
-            <a:pPr algn="ctr" indent="0" marL="0">
-              <a:buNone/>
-            </a:pPr>
-            <a:r>
-              <a:rPr lang="en-US" sz="1300" b="1" dirty="0">
-                <a:solidFill>
-                  <a:srgbClr val="FFFFFF"/>
-                </a:solidFill>
-                <a:latin typeface="Calibri" pitchFamily="34" charset="0"/>
-                <a:ea typeface="Calibri" pitchFamily="34" charset="-122"/>
-                <a:cs typeface="Calibri" pitchFamily="34" charset="-120"/>
-              </a:rPr>
-              <a:t>!</a:t>
-            </a:r>
-            <a:endParaRPr lang="en-US" sz="1300" dirty="0"/>
-          </a:p>
-        </p:txBody>
-      </p:sp>
-      <p:sp>
-        <p:nvSpPr>
-          <p:cNvPr id="36" name="Text 34"/>
-          <p:cNvSpPr/>
-          <p:nvPr/>
-        </p:nvSpPr>
-        <p:spPr>
-          <a:xfrm>
-            <a:off x="1243584" y="5079492"/>
-            <a:ext cx="10058400" cy="438912"/>
-          </a:xfrm>
-          <a:prstGeom prst="rect">
-            <a:avLst/>
-          </a:prstGeom>
-          <a:noFill/>
-          <a:ln/>
-        </p:spPr>
-        <p:txBody>
-          <a:bodyPr wrap="square" lIns="0" tIns="0" rIns="0" bIns="0" rtlCol="0" anchor="t"/>
-          <a:lstStyle/>
-          <a:p>
-            <a:pPr indent="0" marL="0">
-              <a:lnSpc>
-                <a:spcPts val="1200"/>
-              </a:lnSpc>
-              <a:buNone/>
-            </a:pPr>
-            <a:r>
-              <a:rPr lang="en-US" sz="1000" dirty="0">
-                <a:solidFill>
-                  <a:srgbClr val="B4B7BD"/>
-                </a:solidFill>
-                <a:latin typeface="Calibri" pitchFamily="34" charset="0"/>
-                <a:ea typeface="Calibri" pitchFamily="34" charset="-122"/>
-                <a:cs typeface="Calibri" pitchFamily="34" charset="-120"/>
-              </a:rPr>
-              <a:t>rows greatly exceeding real_alerts is CORRECT — the Marketplace integration re-sends every still-open alert on each fetch. Only koi_notification_id identifies an alert. Every widget here de-duplicates on it first.</a:t>
-            </a:r>
-            <a:endParaRPr lang="en-US" sz="1000" dirty="0"/>
-          </a:p>
-        </p:txBody>
-      </p:sp>
     </p:spTree>
   </p:cSld>
   <p:clrMapOvr>
@@ -21888,141 +19499,6 @@
           </a:p>
         </p:txBody>
       </p:sp>
-      <p:sp>
-        <p:nvSpPr>
-          <p:cNvPr id="37" name="Shape 35"/>
-          <p:cNvSpPr/>
-          <p:nvPr/>
-        </p:nvSpPr>
-        <p:spPr>
-          <a:xfrm>
-            <a:off x="548640" y="5239512"/>
-            <a:ext cx="11064240" cy="658368"/>
-          </a:xfrm>
-          <a:prstGeom prst="roundRect">
-            <a:avLst>
-              <a:gd name="adj" fmla="val 6944"/>
-            </a:avLst>
-          </a:prstGeom>
-          <a:solidFill>
-            <a:srgbClr val="1C2026"/>
-          </a:solidFill>
-          <a:ln w="12700">
-            <a:solidFill>
-              <a:srgbClr val="1C2026"/>
-            </a:solidFill>
-            <a:prstDash val="solid"/>
-          </a:ln>
-        </p:spPr>
-      </p:sp>
-      <p:sp>
-        <p:nvSpPr>
-          <p:cNvPr id="38" name="Shape 36"/>
-          <p:cNvSpPr/>
-          <p:nvPr/>
-        </p:nvSpPr>
-        <p:spPr>
-          <a:xfrm>
-            <a:off x="786384" y="5422392"/>
-            <a:ext cx="292608" cy="292608"/>
-          </a:xfrm>
-          <a:prstGeom prst="roundRect">
-            <a:avLst>
-              <a:gd name="adj" fmla="val 28125"/>
-            </a:avLst>
-          </a:prstGeom>
-          <a:solidFill>
-            <a:srgbClr val="F5A524"/>
-          </a:solidFill>
-          <a:ln w="12700">
-            <a:solidFill>
-              <a:srgbClr val="F5A524"/>
-            </a:solidFill>
-            <a:prstDash val="solid"/>
-          </a:ln>
-        </p:spPr>
-      </p:sp>
-      <p:sp>
-        <p:nvSpPr>
-          <p:cNvPr id="39" name="Text 37"/>
-          <p:cNvSpPr/>
-          <p:nvPr/>
-        </p:nvSpPr>
-        <p:spPr>
-          <a:xfrm>
-            <a:off x="786384" y="5422392"/>
-            <a:ext cx="292608" cy="292608"/>
-          </a:xfrm>
-          <a:prstGeom prst="rect">
-            <a:avLst/>
-          </a:prstGeom>
-          <a:noFill/>
-          <a:ln/>
-        </p:spPr>
-        <p:txBody>
-          <a:bodyPr wrap="square" lIns="0" tIns="0" rIns="0" bIns="0" rtlCol="0" anchor="ctr"/>
-          <a:lstStyle/>
-          <a:p>
-            <a:pPr algn="ctr" indent="0" marL="0">
-              <a:buNone/>
-            </a:pPr>
-            <a:r>
-              <a:rPr lang="en-US" sz="1300" b="1" dirty="0">
-                <a:solidFill>
-                  <a:srgbClr val="FFFFFF"/>
-                </a:solidFill>
-                <a:latin typeface="Calibri" pitchFamily="34" charset="0"/>
-                <a:ea typeface="Calibri" pitchFamily="34" charset="-122"/>
-                <a:cs typeface="Calibri" pitchFamily="34" charset="-120"/>
-              </a:rPr>
-              <a:t>!</a:t>
-            </a:r>
-            <a:endParaRPr lang="en-US" sz="1300" dirty="0"/>
-          </a:p>
-        </p:txBody>
-      </p:sp>
-      <p:sp>
-        <p:nvSpPr>
-          <p:cNvPr id="40" name="Text 38"/>
-          <p:cNvSpPr/>
-          <p:nvPr/>
-        </p:nvSpPr>
-        <p:spPr>
-          <a:xfrm>
-            <a:off x="1243584" y="5349240"/>
-            <a:ext cx="10058400" cy="438912"/>
-          </a:xfrm>
-          <a:prstGeom prst="rect">
-            <a:avLst/>
-          </a:prstGeom>
-          <a:noFill/>
-          <a:ln/>
-        </p:spPr>
-        <p:txBody>
-          <a:bodyPr wrap="square" lIns="0" tIns="0" rIns="0" bIns="0" rtlCol="0" anchor="t"/>
-          <a:lstStyle/>
-          <a:p>
-            <a:pPr indent="0" marL="0">
-              <a:lnSpc>
-                <a:spcPts val="1200"/>
-              </a:lnSpc>
-              <a:buNone/>
-            </a:pPr>
-            <a:r>
-              <a:rPr lang="en-US" sz="1000" dirty="0">
-                <a:solidFill>
-                  <a:srgbClr val="B4B7BD"/>
-                </a:solidFill>
-                <a:latin typeface="Calibri" pitchFamily="34" charset="0"/>
-                <a:ea typeface="Calibri" pitchFamily="34" charset="-122"/>
-                <a:cs typeface="Calibri" pitchFamily="34" charset="-120"/>
-              </a:rPr>
-              <a:t>If everything comes out Suspicious, the alert carried no KOI detail for the playbook to read. Check that your correlation rule passes the KOI fields through.</a:t>
-            </a:r>
-            <a:endParaRPr lang="en-US" sz="1000" dirty="0"/>
-          </a:p>
-        </p:txBody>
-      </p:sp>
     </p:spTree>
   </p:cSld>
   <p:clrMapOvr>
@@ -23420,141 +20896,6 @@
               <a:t>With Cortex XDR present, execution evidence is added.</a:t>
             </a:r>
             <a:endParaRPr lang="en-US" sz="1150" dirty="0"/>
-          </a:p>
-        </p:txBody>
-      </p:sp>
-      <p:sp>
-        <p:nvSpPr>
-          <p:cNvPr id="37" name="Shape 35"/>
-          <p:cNvSpPr/>
-          <p:nvPr/>
-        </p:nvSpPr>
-        <p:spPr>
-          <a:xfrm>
-            <a:off x="548640" y="5614416"/>
-            <a:ext cx="11064240" cy="658368"/>
-          </a:xfrm>
-          <a:prstGeom prst="roundRect">
-            <a:avLst>
-              <a:gd name="adj" fmla="val 6944"/>
-            </a:avLst>
-          </a:prstGeom>
-          <a:solidFill>
-            <a:srgbClr val="1C2026"/>
-          </a:solidFill>
-          <a:ln w="12700">
-            <a:solidFill>
-              <a:srgbClr val="1C2026"/>
-            </a:solidFill>
-            <a:prstDash val="solid"/>
-          </a:ln>
-        </p:spPr>
-      </p:sp>
-      <p:sp>
-        <p:nvSpPr>
-          <p:cNvPr id="38" name="Shape 36"/>
-          <p:cNvSpPr/>
-          <p:nvPr/>
-        </p:nvSpPr>
-        <p:spPr>
-          <a:xfrm>
-            <a:off x="786384" y="5797296"/>
-            <a:ext cx="292608" cy="292608"/>
-          </a:xfrm>
-          <a:prstGeom prst="roundRect">
-            <a:avLst>
-              <a:gd name="adj" fmla="val 28125"/>
-            </a:avLst>
-          </a:prstGeom>
-          <a:solidFill>
-            <a:srgbClr val="F5A524"/>
-          </a:solidFill>
-          <a:ln w="12700">
-            <a:solidFill>
-              <a:srgbClr val="F5A524"/>
-            </a:solidFill>
-            <a:prstDash val="solid"/>
-          </a:ln>
-        </p:spPr>
-      </p:sp>
-      <p:sp>
-        <p:nvSpPr>
-          <p:cNvPr id="39" name="Text 37"/>
-          <p:cNvSpPr/>
-          <p:nvPr/>
-        </p:nvSpPr>
-        <p:spPr>
-          <a:xfrm>
-            <a:off x="786384" y="5797296"/>
-            <a:ext cx="292608" cy="292608"/>
-          </a:xfrm>
-          <a:prstGeom prst="rect">
-            <a:avLst/>
-          </a:prstGeom>
-          <a:noFill/>
-          <a:ln/>
-        </p:spPr>
-        <p:txBody>
-          <a:bodyPr wrap="square" lIns="0" tIns="0" rIns="0" bIns="0" rtlCol="0" anchor="ctr"/>
-          <a:lstStyle/>
-          <a:p>
-            <a:pPr algn="ctr" indent="0" marL="0">
-              <a:buNone/>
-            </a:pPr>
-            <a:r>
-              <a:rPr lang="en-US" sz="1300" b="1" dirty="0">
-                <a:solidFill>
-                  <a:srgbClr val="FFFFFF"/>
-                </a:solidFill>
-                <a:latin typeface="Calibri" pitchFamily="34" charset="0"/>
-                <a:ea typeface="Calibri" pitchFamily="34" charset="-122"/>
-                <a:cs typeface="Calibri" pitchFamily="34" charset="-120"/>
-              </a:rPr>
-              <a:t>!</a:t>
-            </a:r>
-            <a:endParaRPr lang="en-US" sz="1300" dirty="0"/>
-          </a:p>
-        </p:txBody>
-      </p:sp>
-      <p:sp>
-        <p:nvSpPr>
-          <p:cNvPr id="40" name="Text 38"/>
-          <p:cNvSpPr/>
-          <p:nvPr/>
-        </p:nvSpPr>
-        <p:spPr>
-          <a:xfrm>
-            <a:off x="1243584" y="5724144"/>
-            <a:ext cx="10058400" cy="438912"/>
-          </a:xfrm>
-          <a:prstGeom prst="rect">
-            <a:avLst/>
-          </a:prstGeom>
-          <a:noFill/>
-          <a:ln/>
-        </p:spPr>
-        <p:txBody>
-          <a:bodyPr wrap="square" lIns="0" tIns="0" rIns="0" bIns="0" rtlCol="0" anchor="t"/>
-          <a:lstStyle/>
-          <a:p>
-            <a:pPr indent="0" marL="0">
-              <a:lnSpc>
-                <a:spcPts val="1200"/>
-              </a:lnSpc>
-              <a:buNone/>
-            </a:pPr>
-            <a:r>
-              <a:rPr lang="en-US" sz="1000" dirty="0">
-                <a:solidFill>
-                  <a:srgbClr val="B4B7BD"/>
-                </a:solidFill>
-                <a:latin typeface="Calibri" pitchFamily="34" charset="0"/>
-                <a:ea typeface="Calibri" pitchFamily="34" charset="-122"/>
-                <a:cs typeface="Calibri" pitchFamily="34" charset="-120"/>
-              </a:rPr>
-              <a:t>This pack builds its device view from inventory filtered by host plus Cortex XDR data. KOI's own device record — last seen, registration, logged-on user — needs the custom integration's device commands and is not available here.</a:t>
-            </a:r>
-            <a:endParaRPr lang="en-US" sz="1000" dirty="0"/>
           </a:p>
         </p:txBody>
       </p:sp>

</xml_diff>

<commit_message>
Separate the pack-install path from the selective-upload path
The guide assumed the content was already on the tenant, which only holds if the whole
pack was installed. A reader uploading items selectively could not tell what a given test
needs — worst on the Script Runner, which needs five playbooks, the KoiScanTracker
automation and a List.

Verified on a tenant: a pack containing only the Lists content item installs the List with
clean content and the playbook parses it, so a pack install really does leave nothing to
paste.

The how-to-use slide now states both paths — pack install means nothing to upload,
selective upload means the PACK CONTENT column is that test's checklist — and the Script
Runner step branches accordingly.

Co-Authored-By: Claude Fable 5 <noreply@anthropic.com>
</commit_message>
<xml_diff>
--- a/docs/KOI_Marketplace_Pack_Test_Guide.pptx
+++ b/docs/KOI_Marketplace_Pack_Test_Guide.pptx
@@ -6066,7 +6066,7 @@
                 <a:ea typeface="Calibri" pitchFamily="34" charset="-122"/>
                 <a:cs typeface="Calibri" pitchFamily="34" charset="-120"/>
               </a:rPr>
-              <a:t>Settings → Object Setup → Lists → New List, type JSON, named exactly Koi Script Runner.</a:t>
+              <a:t>If you installed the pack: the Koi Script Runner List is already there — open Settings → Object Setup → Lists and go to the next step.</a:t>
             </a:r>
             <a:endParaRPr lang="en-US" sz="1150" dirty="0"/>
           </a:p>
@@ -6120,7 +6120,7 @@
         <p:spPr>
           <a:xfrm>
             <a:off x="1152144" y="4279392"/>
-            <a:ext cx="5486400" cy="630936"/>
+            <a:ext cx="5486400" cy="822960"/>
           </a:xfrm>
           <a:prstGeom prst="rect">
             <a:avLst/>
@@ -6147,7 +6147,7 @@
                 <a:ea typeface="Calibri" pitchFamily="34" charset="-122"/>
                 <a:cs typeface="Calibri" pitchFamily="34" charset="-120"/>
               </a:rPr>
-              <a:t>Open Lists/README.md in the pack and copy the JSON block — it is formatted ready to paste (do NOT copy from list-Koi_Script_Runner.json; its data field is escaped).</a:t>
+              <a:t>If you uploaded selectively: upload the playbooks and automation listed under PACK CONTENT, then create the List — New List, type JSON, named exactly Koi Script Runner — and paste the block from Lists/README.md (not from list-Koi_Script_Runner.json; its data field is escaped).</a:t>
             </a:r>
             <a:endParaRPr lang="en-US" sz="1150" dirty="0"/>
           </a:p>
@@ -6161,7 +6161,7 @@
         </p:nvSpPr>
         <p:spPr>
           <a:xfrm>
-            <a:off x="859536" y="4983480"/>
+            <a:off x="859536" y="5170932"/>
             <a:ext cx="219456" cy="256032"/>
           </a:xfrm>
           <a:prstGeom prst="rect">
@@ -6200,7 +6200,7 @@
         </p:nvSpPr>
         <p:spPr>
           <a:xfrm>
-            <a:off x="1152144" y="4983480"/>
+            <a:off x="1152144" y="5170932"/>
             <a:ext cx="5486400" cy="438912"/>
           </a:xfrm>
           <a:prstGeom prst="rect">
@@ -6242,7 +6242,7 @@
         </p:nvSpPr>
         <p:spPr>
           <a:xfrm>
-            <a:off x="859536" y="5500116"/>
+            <a:off x="859536" y="5687568"/>
             <a:ext cx="219456" cy="256032"/>
           </a:xfrm>
           <a:prstGeom prst="rect">
@@ -6281,7 +6281,7 @@
         </p:nvSpPr>
         <p:spPr>
           <a:xfrm>
-            <a:off x="1152144" y="5500116"/>
+            <a:off x="1152144" y="5687568"/>
             <a:ext cx="5486400" cy="438912"/>
           </a:xfrm>
           <a:prstGeom prst="rect">
@@ -6323,7 +6323,7 @@
         </p:nvSpPr>
         <p:spPr>
           <a:xfrm>
-            <a:off x="859536" y="6016752"/>
+            <a:off x="859536" y="6204204"/>
             <a:ext cx="219456" cy="256032"/>
           </a:xfrm>
           <a:prstGeom prst="rect">
@@ -6362,7 +6362,7 @@
         </p:nvSpPr>
         <p:spPr>
           <a:xfrm>
-            <a:off x="1152144" y="6016752"/>
+            <a:off x="1152144" y="6204204"/>
             <a:ext cx="5486400" cy="438912"/>
           </a:xfrm>
           <a:prstGeom prst="rect">
@@ -12732,12 +12732,12 @@
         </p:nvSpPr>
         <p:spPr>
           <a:xfrm>
-            <a:off x="548640" y="3977640"/>
-            <a:ext cx="11064240" cy="1371600"/>
+            <a:off x="548640" y="3950208"/>
+            <a:ext cx="11064240" cy="1874520"/>
           </a:xfrm>
           <a:prstGeom prst="roundRect">
             <a:avLst>
-              <a:gd name="adj" fmla="val 3333"/>
+              <a:gd name="adj" fmla="val 2439"/>
             </a:avLst>
           </a:prstGeom>
           <a:solidFill>
@@ -12759,8 +12759,8 @@
         </p:nvSpPr>
         <p:spPr>
           <a:xfrm>
-            <a:off x="859536" y="4160520"/>
-            <a:ext cx="4572000" cy="274320"/>
+            <a:off x="859536" y="4114800"/>
+            <a:ext cx="6400800" cy="274320"/>
           </a:xfrm>
           <a:prstGeom prst="rect">
             <a:avLst/>
@@ -12784,7 +12784,7 @@
                 <a:ea typeface="Calibri" pitchFamily="34" charset="-122"/>
                 <a:cs typeface="Calibri" pitchFamily="34" charset="-120"/>
               </a:rPr>
-              <a:t>Run them in order the first time</a:t>
+              <a:t>Installed the pack, or uploading piece by piece?</a:t>
             </a:r>
             <a:endParaRPr lang="en-US" sz="1300" dirty="0"/>
           </a:p>
@@ -12798,8 +12798,8 @@
         </p:nvSpPr>
         <p:spPr>
           <a:xfrm>
-            <a:off x="859536" y="4498848"/>
-            <a:ext cx="10442448" cy="731520"/>
+            <a:off x="859536" y="4434840"/>
+            <a:ext cx="10442448" cy="548640"/>
           </a:xfrm>
           <a:prstGeom prst="rect">
             <a:avLst/>
@@ -12826,6 +12826,87 @@
                 <a:ea typeface="Calibri" pitchFamily="34" charset="-122"/>
                 <a:cs typeface="Calibri" pitchFamily="34" charset="-120"/>
               </a:rPr>
+              <a:t>Install the whole pack and every playbook, automation, rule and the Koi Script Runner List are already on the tenant — nothing to upload. If you upload selectively instead, the PACK CONTENT column on each test is your upload checklist for that test.</a:t>
+            </a:r>
+            <a:endParaRPr lang="en-US" sz="1100" dirty="0"/>
+          </a:p>
+        </p:txBody>
+      </p:sp>
+      <p:sp>
+        <p:nvSpPr>
+          <p:cNvPr id="16" name="Text 14"/>
+          <p:cNvSpPr/>
+          <p:nvPr/>
+        </p:nvSpPr>
+        <p:spPr>
+          <a:xfrm>
+            <a:off x="859536" y="5029200"/>
+            <a:ext cx="4572000" cy="274320"/>
+          </a:xfrm>
+          <a:prstGeom prst="rect">
+            <a:avLst/>
+          </a:prstGeom>
+          <a:noFill/>
+          <a:ln/>
+        </p:spPr>
+        <p:txBody>
+          <a:bodyPr wrap="square" lIns="0" tIns="0" rIns="0" bIns="0" rtlCol="0" anchor="t"/>
+          <a:lstStyle/>
+          <a:p>
+            <a:pPr indent="0" marL="0">
+              <a:buNone/>
+            </a:pPr>
+            <a:r>
+              <a:rPr lang="en-US" sz="1300" b="1" dirty="0">
+                <a:solidFill>
+                  <a:srgbClr val="FFFFFF"/>
+                </a:solidFill>
+                <a:latin typeface="Calibri" pitchFamily="34" charset="0"/>
+                <a:ea typeface="Calibri" pitchFamily="34" charset="-122"/>
+                <a:cs typeface="Calibri" pitchFamily="34" charset="-120"/>
+              </a:rPr>
+              <a:t>Run them in order the first time</a:t>
+            </a:r>
+            <a:endParaRPr lang="en-US" sz="1300" dirty="0"/>
+          </a:p>
+        </p:txBody>
+      </p:sp>
+      <p:sp>
+        <p:nvSpPr>
+          <p:cNvPr id="17" name="Text 15"/>
+          <p:cNvSpPr/>
+          <p:nvPr/>
+        </p:nvSpPr>
+        <p:spPr>
+          <a:xfrm>
+            <a:off x="859536" y="5349240"/>
+            <a:ext cx="10442448" cy="502920"/>
+          </a:xfrm>
+          <a:prstGeom prst="rect">
+            <a:avLst/>
+          </a:prstGeom>
+          <a:noFill/>
+          <a:ln/>
+        </p:spPr>
+        <p:txBody>
+          <a:bodyPr wrap="square" lIns="0" tIns="0" rIns="0" bIns="0" rtlCol="0" anchor="t"/>
+          <a:lstStyle/>
+          <a:p>
+            <a:pPr indent="0" marL="0">
+              <a:lnSpc>
+                <a:spcPts val="1300"/>
+              </a:lnSpc>
+              <a:buNone/>
+            </a:pPr>
+            <a:r>
+              <a:rPr lang="en-US" sz="1100" dirty="0">
+                <a:solidFill>
+                  <a:srgbClr val="B4B7BD"/>
+                </a:solidFill>
+                <a:latin typeface="Calibri" pitchFamily="34" charset="0"/>
+                <a:ea typeface="Calibri" pitchFamily="34" charset="-122"/>
+                <a:cs typeface="Calibri" pitchFamily="34" charset="-120"/>
+              </a:rPr>
               <a:t>Tests 1 to 3 prove data is arriving and correct. Tests 4 to 7 prove the automation. Tests 8 and 9 prove fleet script execution — the only ones needing the Core REST API integration. Test 10 is the alert layout. Nothing here needs a Cortex XDR integration: XSIAM is the XDR, and its XQL engine is built in.</a:t>
             </a:r>
             <a:endParaRPr lang="en-US" sz="1100" dirty="0"/>
@@ -12834,13 +12915,13 @@
       </p:sp>
       <p:sp>
         <p:nvSpPr>
-          <p:cNvPr id="16" name="Text 14"/>
-          <p:cNvSpPr/>
-          <p:nvPr/>
-        </p:nvSpPr>
-        <p:spPr>
-          <a:xfrm>
-            <a:off x="548640" y="5623560"/>
+          <p:cNvPr id="18" name="Text 16"/>
+          <p:cNvSpPr/>
+          <p:nvPr/>
+        </p:nvSpPr>
+        <p:spPr>
+          <a:xfrm>
+            <a:off x="548640" y="6035040"/>
             <a:ext cx="11064240" cy="274320"/>
           </a:xfrm>
           <a:prstGeom prst="rect">

</xml_diff>

<commit_message>
Name the file NOT to upload for a manual KoiScanTracker import
The guide named dist/automation-KoiScanTracker.yml but never named the file people
actually keep opening. It now says explicitly not to upload
Scripts/KoiScanTracker/KoiScanTracker.yml, and why: that file reads script: '-' by
design and would import an empty automation.

Co-Authored-By: Claude Fable 5 <noreply@anthropic.com>
</commit_message>
<xml_diff>
--- a/docs/KOI_Marketplace_Pack_Test_Guide.pptx
+++ b/docs/KOI_Marketplace_Pack_Test_Guide.pptx
@@ -5636,7 +5636,7 @@
                 <a:ea typeface="Calibri" pitchFamily="34" charset="-122"/>
                 <a:cs typeface="Calibri" pitchFamily="34" charset="-120"/>
               </a:rPr>
-              <a:t>KoiScanTracker — an automation, not a playbook. Ours, and different from the KOI deployment script opposite. For manual upload use dist/automation-KoiScanTracker.yml (one file).</a:t>
+              <a:t>KoiScanTracker — an automation, not a playbook. Ours, and different from the KOI deployment script opposite. Manual upload takes exactly one file: dist/automation-KoiScanTracker.yml</a:t>
             </a:r>
             <a:endParaRPr lang="en-US" sz="1050" dirty="0"/>
           </a:p>
@@ -6227,7 +6227,7 @@
         <p:spPr>
           <a:xfrm>
             <a:off x="1152144" y="5394960"/>
-            <a:ext cx="10149840" cy="438912"/>
+            <a:ext cx="10149840" cy="246888"/>
           </a:xfrm>
           <a:prstGeom prst="rect">
             <a:avLst/>
@@ -6254,7 +6254,7 @@
                 <a:ea typeface="Calibri" pitchFamily="34" charset="-122"/>
                 <a:cs typeface="Calibri" pitchFamily="34" charset="-120"/>
               </a:rPr>
-              <a:t>Automation → Scripts → Import for KoiScanTracker — upload dist/automation-KoiScanTracker.yml. One file, code already inside; do not upload the two files under Scripts/.</a:t>
+              <a:t>Automation → Scripts → Import → dist/automation-KoiScanTracker.yml. Open it first and you will see the Python inside it.</a:t>
             </a:r>
             <a:endParaRPr lang="en-US" sz="1150" dirty="0"/>
           </a:p>
@@ -6268,7 +6268,7 @@
         </p:nvSpPr>
         <p:spPr>
           <a:xfrm>
-            <a:off x="859536" y="5911596"/>
+            <a:off x="859536" y="5724144"/>
             <a:ext cx="219456" cy="256032"/>
           </a:xfrm>
           <a:prstGeom prst="rect">
@@ -6307,7 +6307,7 @@
         </p:nvSpPr>
         <p:spPr>
           <a:xfrm>
-            <a:off x="1152144" y="5911596"/>
+            <a:off x="1152144" y="5724144"/>
             <a:ext cx="10149840" cy="246888"/>
           </a:xfrm>
           <a:prstGeom prst="rect">
@@ -6335,6 +6335,87 @@
                 <a:ea typeface="Calibri" pitchFamily="34" charset="-122"/>
                 <a:cs typeface="Calibri" pitchFamily="34" charset="-120"/>
               </a:rPr>
+              <a:t>Not Scripts/KoiScanTracker/KoiScanTracker.yml — that file reads script: '-' on purpose and would import an empty automation.</a:t>
+            </a:r>
+            <a:endParaRPr lang="en-US" sz="1150" dirty="0"/>
+          </a:p>
+        </p:txBody>
+      </p:sp>
+      <p:sp>
+        <p:nvSpPr>
+          <p:cNvPr id="32" name="Text 30"/>
+          <p:cNvSpPr/>
+          <p:nvPr/>
+        </p:nvSpPr>
+        <p:spPr>
+          <a:xfrm>
+            <a:off x="859536" y="6053328"/>
+            <a:ext cx="219456" cy="256032"/>
+          </a:xfrm>
+          <a:prstGeom prst="rect">
+            <a:avLst/>
+          </a:prstGeom>
+          <a:noFill/>
+          <a:ln/>
+        </p:spPr>
+        <p:txBody>
+          <a:bodyPr wrap="square" lIns="0" tIns="0" rIns="0" bIns="0" rtlCol="0" anchor="t"/>
+          <a:lstStyle/>
+          <a:p>
+            <a:pPr indent="0" marL="0">
+              <a:buNone/>
+            </a:pPr>
+            <a:r>
+              <a:rPr lang="en-US" sz="1150" b="1" dirty="0">
+                <a:solidFill>
+                  <a:srgbClr val="E8551F"/>
+                </a:solidFill>
+                <a:latin typeface="Calibri" pitchFamily="34" charset="0"/>
+                <a:ea typeface="Calibri" pitchFamily="34" charset="-122"/>
+                <a:cs typeface="Calibri" pitchFamily="34" charset="-120"/>
+              </a:rPr>
+              <a:t>5</a:t>
+            </a:r>
+            <a:endParaRPr lang="en-US" sz="1150" dirty="0"/>
+          </a:p>
+        </p:txBody>
+      </p:sp>
+      <p:sp>
+        <p:nvSpPr>
+          <p:cNvPr id="33" name="Text 31"/>
+          <p:cNvSpPr/>
+          <p:nvPr/>
+        </p:nvSpPr>
+        <p:spPr>
+          <a:xfrm>
+            <a:off x="1152144" y="6053328"/>
+            <a:ext cx="10149840" cy="246888"/>
+          </a:xfrm>
+          <a:prstGeom prst="rect">
+            <a:avLst/>
+          </a:prstGeom>
+          <a:noFill/>
+          <a:ln/>
+        </p:spPr>
+        <p:txBody>
+          <a:bodyPr wrap="square" lIns="0" tIns="0" rIns="0" bIns="0" rtlCol="0" anchor="t"/>
+          <a:lstStyle/>
+          <a:p>
+            <a:pPr indent="0" marL="0">
+              <a:lnSpc>
+                <a:spcPts val="1500"/>
+              </a:lnSpc>
+              <a:buNone/>
+            </a:pPr>
+            <a:r>
+              <a:rPr lang="en-US" sz="1150" dirty="0">
+                <a:solidFill>
+                  <a:srgbClr val="B4B7BD"/>
+                </a:solidFill>
+                <a:latin typeface="Calibri" pitchFamily="34" charset="0"/>
+                <a:ea typeface="Calibri" pitchFamily="34" charset="-122"/>
+                <a:cs typeface="Calibri" pitchFamily="34" charset="-120"/>
+              </a:rPr>
               <a:t>Settings → Object Setup → Lists → New List, type JSON, named exactly Koi Script Runner. Paste the block from Lists/README.md.</a:t>
             </a:r>
             <a:endParaRPr lang="en-US" sz="1150" dirty="0"/>
@@ -6343,13 +6424,13 @@
       </p:sp>
       <p:sp>
         <p:nvSpPr>
-          <p:cNvPr id="32" name="Text 30"/>
-          <p:cNvSpPr/>
-          <p:nvPr/>
-        </p:nvSpPr>
-        <p:spPr>
-          <a:xfrm>
-            <a:off x="859536" y="6240780"/>
+          <p:cNvPr id="34" name="Text 32"/>
+          <p:cNvSpPr/>
+          <p:nvPr/>
+        </p:nvSpPr>
+        <p:spPr>
+          <a:xfrm>
+            <a:off x="859536" y="6382512"/>
             <a:ext cx="219456" cy="256032"/>
           </a:xfrm>
           <a:prstGeom prst="rect">
@@ -6374,7 +6455,7 @@
                 <a:ea typeface="Calibri" pitchFamily="34" charset="-122"/>
                 <a:cs typeface="Calibri" pitchFamily="34" charset="-120"/>
               </a:rPr>
-              <a:t>5</a:t>
+              <a:t>6</a:t>
             </a:r>
             <a:endParaRPr lang="en-US" sz="1150" dirty="0"/>
           </a:p>
@@ -6382,13 +6463,13 @@
       </p:sp>
       <p:sp>
         <p:nvSpPr>
-          <p:cNvPr id="33" name="Text 31"/>
-          <p:cNvSpPr/>
-          <p:nvPr/>
-        </p:nvSpPr>
-        <p:spPr>
-          <a:xfrm>
-            <a:off x="1152144" y="6240780"/>
+          <p:cNvPr id="35" name="Text 33"/>
+          <p:cNvSpPr/>
+          <p:nvPr/>
+        </p:nvSpPr>
+        <p:spPr>
+          <a:xfrm>
+            <a:off x="1152144" y="6382512"/>
             <a:ext cx="10149840" cy="246888"/>
           </a:xfrm>
           <a:prstGeom prst="rect">

</xml_diff>